<commit_message>
Remove individual contribution slides; retain complete project architecture and concepts (11 slides)
</commit_message>
<xml_diff>
--- a/Online_Quiz_Management_System_Presentation.pptx
+++ b/Online_Quiz_Management_System_Presentation.pptx
@@ -16,11 +16,6 @@
     <p:sldId id="264" r:id="rId15"/>
     <p:sldId id="265" r:id="rId16"/>
     <p:sldId id="266" r:id="rId17"/>
-    <p:sldId id="267" r:id="rId18"/>
-    <p:sldId id="268" r:id="rId19"/>
-    <p:sldId id="269" r:id="rId20"/>
-    <p:sldId id="270" r:id="rId21"/>
-    <p:sldId id="271" r:id="rId22"/>
   </p:sldIdLst>
   <p:sldSz cx="12191695" cy="6858000" type="screen4x3"/>
   <p:notesSz cx="6858000" cy="9144000"/>
@@ -3438,10 +3433,10 @@
                 </a:solidFill>
               </a:rPr>
               <a:t>
-      1. Aditya Yadav — Roll No: 8108 (Group Leader &amp; Architect)
-      2. Abhishekh Singh — Roll No: 8104 (Polymorphic Questions &amp; Dispatch)
-      3. Priyam Raj — Roll No: 8134 (Interfaces &amp; Strategy Pattern)
-      4. Utkarsh Chauhan — Roll No: 8154 (Custom Exceptions &amp; QA)</a:t>
+      1. Aditya Yadav — Roll No: 8108 (Group Leader)
+      2. Abhishekh Singh — Roll No: 8104
+      3. Priyam Raj — Roll No: 8134
+      4. Utkarsh Chauhan — Roll No: 8154</a:t>
             </a:r>
           </a:p>
         </p:txBody>
@@ -4450,7 +4445,7 @@
               </a:defRPr>
             </a:pPr>
             <a:r>
-              <a:t>INDIVIDUAL CONTRIBUTION &amp; WORK ALLOCATION (SE IT B)</a:t>
+              <a:t>CONTINUOUS PROJECT ROADMAP &amp; ACADEMIC REFERENCES</a:t>
             </a:r>
           </a:p>
           <a:p>
@@ -4463,7 +4458,7 @@
               </a:defRPr>
             </a:pPr>
             <a:r>
-              <a:t>EXPLICIT RUBRIC RESPONSIBILITY MATRIX: UNIT III &amp; UNIT IV TOPIC MAPPING</a:t>
+              <a:t>EXPANSION PHASES &amp; OFFICIAL COURSE CITATIONS</a:t>
             </a:r>
           </a:p>
         </p:txBody>
@@ -4524,3779 +4519,6 @@
             </a:pPr>
             <a:r>
               <a:t>11</a:t>
-            </a:r>
-          </a:p>
-        </p:txBody>
-      </p:sp>
-      <p:sp>
-        <p:nvSpPr>
-          <p:cNvPr id="7" name="Rounded Rectangle 6"/>
-          <p:cNvSpPr/>
-          <p:nvPr/>
-        </p:nvSpPr>
-        <p:spPr>
-          <a:xfrm>
-            <a:off x="731520" y="1463040"/>
-            <a:ext cx="5212080" cy="2377440"/>
-          </a:xfrm>
-          <a:prstGeom prst="roundRect">
-            <a:avLst/>
-          </a:prstGeom>
-          <a:solidFill>
-            <a:srgbClr val="FFFFFF"/>
-          </a:solidFill>
-          <a:ln w="19050">
-            <a:solidFill>
-              <a:srgbClr val="E2E8F0"/>
-            </a:solidFill>
-          </a:ln>
-        </p:spPr>
-        <p:style>
-          <a:lnRef idx="1">
-            <a:schemeClr val="accent1"/>
-          </a:lnRef>
-          <a:fillRef idx="3">
-            <a:schemeClr val="accent1"/>
-          </a:fillRef>
-          <a:effectRef idx="2">
-            <a:schemeClr val="accent1"/>
-          </a:effectRef>
-          <a:fontRef idx="minor">
-            <a:schemeClr val="lt1"/>
-          </a:fontRef>
-        </p:style>
-        <p:txBody>
-          <a:bodyPr rtlCol="0" anchor="ctr" wrap="square" lIns="182880" rIns="182880" tIns="164592" bIns="164592"/>
-          <a:lstStyle/>
-          <a:p>
-            <a:pPr algn="ctr">
-              <a:spcAft>
-                <a:spcPts val="200"/>
-              </a:spcAft>
-              <a:defRPr sz="850" b="1">
-                <a:solidFill>
-                  <a:srgbClr val="2563EB"/>
-                </a:solidFill>
-                <a:latin typeface="Arial"/>
-              </a:defRPr>
-            </a:pPr>
-            <a:r>
-              <a:t>TEAM MEMBER (IT B)</a:t>
-            </a:r>
-          </a:p>
-          <a:p>
-            <a:pPr>
-              <a:spcAft>
-                <a:spcPts val="400"/>
-              </a:spcAft>
-              <a:defRPr sz="1200" b="1">
-                <a:solidFill>
-                  <a:srgbClr val="1B365D"/>
-                </a:solidFill>
-                <a:latin typeface="Arial"/>
-              </a:defRPr>
-            </a:pPr>
-            <a:r>
-              <a:t>Aditya Yadav (Roll No: 8108)</a:t>
-            </a:r>
-          </a:p>
-          <a:p>
-            <a:pPr>
-              <a:spcAft>
-                <a:spcPts val="300"/>
-              </a:spcAft>
-            </a:pPr>
-            <a:r>
-              <a:rPr b="1" sz="850">
-                <a:solidFill>
-                  <a:srgbClr val="0F172A"/>
-                </a:solidFill>
-                <a:latin typeface="Arial"/>
-              </a:rPr>
-              <a:t>Assigned Role — </a:t>
-            </a:r>
-            <a:r>
-              <a:rPr sz="850">
-                <a:solidFill>
-                  <a:srgbClr val="0F172A"/>
-                </a:solidFill>
-                <a:latin typeface="Arial"/>
-              </a:rPr>
-              <a:t>Group Leader &amp; System Architect</a:t>
-            </a:r>
-          </a:p>
-          <a:p>
-            <a:pPr>
-              <a:spcAft>
-                <a:spcPts val="300"/>
-              </a:spcAft>
-            </a:pPr>
-            <a:r>
-              <a:rPr b="1" sz="850">
-                <a:solidFill>
-                  <a:srgbClr val="0F172A"/>
-                </a:solidFill>
-                <a:latin typeface="Arial"/>
-              </a:rPr>
-              <a:t>Unit III Allocation — </a:t>
-            </a:r>
-            <a:r>
-              <a:rPr sz="850">
-                <a:solidFill>
-                  <a:srgbClr val="0F172A"/>
-                </a:solidFill>
-                <a:latin typeface="Arial"/>
-              </a:rPr>
-              <a:t>Abstract Classes &amp; Methods (Question &amp; User hierarchies)</a:t>
-            </a:r>
-          </a:p>
-          <a:p>
-            <a:pPr>
-              <a:spcAft>
-                <a:spcPts val="300"/>
-              </a:spcAft>
-            </a:pPr>
-            <a:r>
-              <a:rPr b="1" sz="850">
-                <a:solidFill>
-                  <a:srgbClr val="0F172A"/>
-                </a:solidFill>
-                <a:latin typeface="Arial"/>
-              </a:rPr>
-              <a:t>Unit IV Allocation — </a:t>
-            </a:r>
-            <a:r>
-              <a:rPr sz="850">
-                <a:solidFill>
-                  <a:srgbClr val="0F172A"/>
-                </a:solidFill>
-                <a:latin typeface="Arial"/>
-              </a:rPr>
-              <a:t>Types of Errors &amp; Compile-Time Parameter Validation</a:t>
-            </a:r>
-          </a:p>
-          <a:p>
-            <a:pPr>
-              <a:spcAft>
-                <a:spcPts val="300"/>
-              </a:spcAft>
-            </a:pPr>
-            <a:r>
-              <a:rPr b="1" sz="850">
-                <a:solidFill>
-                  <a:srgbClr val="0F172A"/>
-                </a:solidFill>
-                <a:latin typeface="Arial"/>
-              </a:rPr>
-              <a:t>Core Implementation — </a:t>
-            </a:r>
-            <a:r>
-              <a:rPr sz="850">
-                <a:solidFill>
-                  <a:srgbClr val="0F172A"/>
-                </a:solidFill>
-                <a:latin typeface="Arial"/>
-              </a:rPr>
-              <a:t>abstract class Question, User, constructor boundary checks, and Quiz model aggregation.</a:t>
-            </a:r>
-          </a:p>
-          <a:p>
-            <a:pPr>
-              <a:spcAft>
-                <a:spcPts val="300"/>
-              </a:spcAft>
-            </a:pPr>
-            <a:r>
-              <a:rPr b="1" sz="850">
-                <a:solidFill>
-                  <a:srgbClr val="0F172A"/>
-                </a:solidFill>
-                <a:latin typeface="Arial"/>
-              </a:rPr>
-              <a:t>Viva Focus — </a:t>
-            </a:r>
-            <a:r>
-              <a:rPr sz="850">
-                <a:solidFill>
-                  <a:srgbClr val="0F172A"/>
-                </a:solidFill>
-                <a:latin typeface="Arial"/>
-              </a:rPr>
-              <a:t>Why use an abstract class? What is the difference between an abstract class and an interface?</a:t>
-            </a:r>
-          </a:p>
-        </p:txBody>
-      </p:sp>
-      <p:sp>
-        <p:nvSpPr>
-          <p:cNvPr id="8" name="Rounded Rectangle 7"/>
-          <p:cNvSpPr/>
-          <p:nvPr/>
-        </p:nvSpPr>
-        <p:spPr>
-          <a:xfrm>
-            <a:off x="6217920" y="1463040"/>
-            <a:ext cx="5212080" cy="2377440"/>
-          </a:xfrm>
-          <a:prstGeom prst="roundRect">
-            <a:avLst/>
-          </a:prstGeom>
-          <a:solidFill>
-            <a:srgbClr val="FFFFFF"/>
-          </a:solidFill>
-          <a:ln w="19050">
-            <a:solidFill>
-              <a:srgbClr val="E2E8F0"/>
-            </a:solidFill>
-          </a:ln>
-        </p:spPr>
-        <p:style>
-          <a:lnRef idx="1">
-            <a:schemeClr val="accent1"/>
-          </a:lnRef>
-          <a:fillRef idx="3">
-            <a:schemeClr val="accent1"/>
-          </a:fillRef>
-          <a:effectRef idx="2">
-            <a:schemeClr val="accent1"/>
-          </a:effectRef>
-          <a:fontRef idx="minor">
-            <a:schemeClr val="lt1"/>
-          </a:fontRef>
-        </p:style>
-        <p:txBody>
-          <a:bodyPr rtlCol="0" anchor="ctr" wrap="square" lIns="182880" rIns="182880" tIns="164592" bIns="164592"/>
-          <a:lstStyle/>
-          <a:p>
-            <a:pPr algn="ctr">
-              <a:spcAft>
-                <a:spcPts val="200"/>
-              </a:spcAft>
-              <a:defRPr sz="850" b="1">
-                <a:solidFill>
-                  <a:srgbClr val="2563EB"/>
-                </a:solidFill>
-                <a:latin typeface="Arial"/>
-              </a:defRPr>
-            </a:pPr>
-            <a:r>
-              <a:t>TEAM MEMBER (IT B)</a:t>
-            </a:r>
-          </a:p>
-          <a:p>
-            <a:pPr>
-              <a:spcAft>
-                <a:spcPts val="400"/>
-              </a:spcAft>
-              <a:defRPr sz="1200" b="1">
-                <a:solidFill>
-                  <a:srgbClr val="1B365D"/>
-                </a:solidFill>
-                <a:latin typeface="Arial"/>
-              </a:defRPr>
-            </a:pPr>
-            <a:r>
-              <a:t>Abhishekh Singh (Roll No: 8104)</a:t>
-            </a:r>
-          </a:p>
-          <a:p>
-            <a:pPr>
-              <a:spcAft>
-                <a:spcPts val="300"/>
-              </a:spcAft>
-            </a:pPr>
-            <a:r>
-              <a:rPr b="1" sz="850">
-                <a:solidFill>
-                  <a:srgbClr val="0F172A"/>
-                </a:solidFill>
-                <a:latin typeface="Arial"/>
-              </a:rPr>
-              <a:t>Assigned Role — </a:t>
-            </a:r>
-            <a:r>
-              <a:rPr sz="850">
-                <a:solidFill>
-                  <a:srgbClr val="0F172A"/>
-                </a:solidFill>
-                <a:latin typeface="Arial"/>
-              </a:rPr>
-              <a:t>Polymorphic Question Specialist &amp; Core Dev</a:t>
-            </a:r>
-          </a:p>
-          <a:p>
-            <a:pPr>
-              <a:spcAft>
-                <a:spcPts val="300"/>
-              </a:spcAft>
-            </a:pPr>
-            <a:r>
-              <a:rPr b="1" sz="850">
-                <a:solidFill>
-                  <a:srgbClr val="0F172A"/>
-                </a:solidFill>
-                <a:latin typeface="Arial"/>
-              </a:rPr>
-              <a:t>Unit III Allocation — </a:t>
-            </a:r>
-            <a:r>
-              <a:rPr sz="850">
-                <a:solidFill>
-                  <a:srgbClr val="0F172A"/>
-                </a:solidFill>
-                <a:latin typeface="Arial"/>
-              </a:rPr>
-              <a:t>Polymorphism, Method Overriding &amp; Dynamic Binding (vtable)</a:t>
-            </a:r>
-          </a:p>
-          <a:p>
-            <a:pPr>
-              <a:spcAft>
-                <a:spcPts val="300"/>
-              </a:spcAft>
-            </a:pPr>
-            <a:r>
-              <a:rPr b="1" sz="850">
-                <a:solidFill>
-                  <a:srgbClr val="0F172A"/>
-                </a:solidFill>
-                <a:latin typeface="Arial"/>
-              </a:rPr>
-              <a:t>Unit IV Allocation — </a:t>
-            </a:r>
-            <a:r>
-              <a:rPr sz="850">
-                <a:solidFill>
-                  <a:srgbClr val="0F172A"/>
-                </a:solidFill>
-                <a:latin typeface="Arial"/>
-              </a:rPr>
-              <a:t>Types of Exceptions (Checked vs Unchecked) &amp; Propagation</a:t>
-            </a:r>
-          </a:p>
-          <a:p>
-            <a:pPr>
-              <a:spcAft>
-                <a:spcPts val="300"/>
-              </a:spcAft>
-            </a:pPr>
-            <a:r>
-              <a:rPr b="1" sz="850">
-                <a:solidFill>
-                  <a:srgbClr val="0F172A"/>
-                </a:solidFill>
-                <a:latin typeface="Arial"/>
-              </a:rPr>
-              <a:t>Core Implementation — </a:t>
-            </a:r>
-            <a:r>
-              <a:rPr sz="850">
-                <a:solidFill>
-                  <a:srgbClr val="0F172A"/>
-                </a:solidFill>
-                <a:latin typeface="Arial"/>
-              </a:rPr>
-              <a:t>MultipleChoiceQuestion, TrueFalseQuestion, NumericQuestion, and overloaded searchQuiz().</a:t>
-            </a:r>
-          </a:p>
-          <a:p>
-            <a:pPr>
-              <a:spcAft>
-                <a:spcPts val="300"/>
-              </a:spcAft>
-            </a:pPr>
-            <a:r>
-              <a:rPr b="1" sz="850">
-                <a:solidFill>
-                  <a:srgbClr val="0F172A"/>
-                </a:solidFill>
-                <a:latin typeface="Arial"/>
-              </a:rPr>
-              <a:t>Viva Focus — </a:t>
-            </a:r>
-            <a:r>
-              <a:rPr sz="850">
-                <a:solidFill>
-                  <a:srgbClr val="0F172A"/>
-                </a:solidFill>
-                <a:latin typeface="Arial"/>
-              </a:rPr>
-              <a:t>Where is runtime polymorphism used? How does dynamic method dispatch resolve method calls via vtable?</a:t>
-            </a:r>
-          </a:p>
-        </p:txBody>
-      </p:sp>
-      <p:sp>
-        <p:nvSpPr>
-          <p:cNvPr id="9" name="Rounded Rectangle 8"/>
-          <p:cNvSpPr/>
-          <p:nvPr/>
-        </p:nvSpPr>
-        <p:spPr>
-          <a:xfrm>
-            <a:off x="731520" y="3977639"/>
-            <a:ext cx="5212080" cy="2377440"/>
-          </a:xfrm>
-          <a:prstGeom prst="roundRect">
-            <a:avLst/>
-          </a:prstGeom>
-          <a:solidFill>
-            <a:srgbClr val="FFFFFF"/>
-          </a:solidFill>
-          <a:ln w="19050">
-            <a:solidFill>
-              <a:srgbClr val="E2E8F0"/>
-            </a:solidFill>
-          </a:ln>
-        </p:spPr>
-        <p:style>
-          <a:lnRef idx="1">
-            <a:schemeClr val="accent1"/>
-          </a:lnRef>
-          <a:fillRef idx="3">
-            <a:schemeClr val="accent1"/>
-          </a:fillRef>
-          <a:effectRef idx="2">
-            <a:schemeClr val="accent1"/>
-          </a:effectRef>
-          <a:fontRef idx="minor">
-            <a:schemeClr val="lt1"/>
-          </a:fontRef>
-        </p:style>
-        <p:txBody>
-          <a:bodyPr rtlCol="0" anchor="ctr" wrap="square" lIns="182880" rIns="182880" tIns="164592" bIns="164592"/>
-          <a:lstStyle/>
-          <a:p>
-            <a:pPr algn="ctr">
-              <a:spcAft>
-                <a:spcPts val="200"/>
-              </a:spcAft>
-              <a:defRPr sz="850" b="1">
-                <a:solidFill>
-                  <a:srgbClr val="2563EB"/>
-                </a:solidFill>
-                <a:latin typeface="Arial"/>
-              </a:defRPr>
-            </a:pPr>
-            <a:r>
-              <a:t>TEAM MEMBER (IT B)</a:t>
-            </a:r>
-          </a:p>
-          <a:p>
-            <a:pPr>
-              <a:spcAft>
-                <a:spcPts val="400"/>
-              </a:spcAft>
-              <a:defRPr sz="1200" b="1">
-                <a:solidFill>
-                  <a:srgbClr val="1B365D"/>
-                </a:solidFill>
-                <a:latin typeface="Arial"/>
-              </a:defRPr>
-            </a:pPr>
-            <a:r>
-              <a:t>Priyam Raj (Roll No: 8134)</a:t>
-            </a:r>
-          </a:p>
-          <a:p>
-            <a:pPr>
-              <a:spcAft>
-                <a:spcPts val="300"/>
-              </a:spcAft>
-            </a:pPr>
-            <a:r>
-              <a:rPr b="1" sz="850">
-                <a:solidFill>
-                  <a:srgbClr val="0F172A"/>
-                </a:solidFill>
-                <a:latin typeface="Arial"/>
-              </a:rPr>
-              <a:t>Assigned Role — </a:t>
-            </a:r>
-            <a:r>
-              <a:rPr sz="850">
-                <a:solidFill>
-                  <a:srgbClr val="0F172A"/>
-                </a:solidFill>
-                <a:latin typeface="Arial"/>
-              </a:rPr>
-              <a:t>Service &amp; Strategy Pattern Engineer</a:t>
-            </a:r>
-          </a:p>
-          <a:p>
-            <a:pPr>
-              <a:spcAft>
-                <a:spcPts val="300"/>
-              </a:spcAft>
-            </a:pPr>
-            <a:r>
-              <a:rPr b="1" sz="850">
-                <a:solidFill>
-                  <a:srgbClr val="0F172A"/>
-                </a:solidFill>
-                <a:latin typeface="Arial"/>
-              </a:rPr>
-              <a:t>Unit III Allocation — </a:t>
-            </a:r>
-            <a:r>
-              <a:rPr sz="850">
-                <a:solidFill>
-                  <a:srgbClr val="0F172A"/>
-                </a:solidFill>
-                <a:latin typeface="Arial"/>
-              </a:rPr>
-              <a:t>Interfaces &amp; Behavioral Contracts (Strategy Design Pattern)</a:t>
-            </a:r>
-          </a:p>
-          <a:p>
-            <a:pPr>
-              <a:spcAft>
-                <a:spcPts val="300"/>
-              </a:spcAft>
-            </a:pPr>
-            <a:r>
-              <a:rPr b="1" sz="850">
-                <a:solidFill>
-                  <a:srgbClr val="0F172A"/>
-                </a:solidFill>
-                <a:latin typeface="Arial"/>
-              </a:rPr>
-              <a:t>Unit IV Allocation — </a:t>
-            </a:r>
-            <a:r>
-              <a:rPr sz="850">
-                <a:solidFill>
-                  <a:srgbClr val="0F172A"/>
-                </a:solidFill>
-                <a:latin typeface="Arial"/>
-              </a:rPr>
-              <a:t>Exception Handling Mechanism (try, catch, finally, throws)</a:t>
-            </a:r>
-          </a:p>
-          <a:p>
-            <a:pPr>
-              <a:spcAft>
-                <a:spcPts val="300"/>
-              </a:spcAft>
-            </a:pPr>
-            <a:r>
-              <a:rPr b="1" sz="850">
-                <a:solidFill>
-                  <a:srgbClr val="0F172A"/>
-                </a:solidFill>
-                <a:latin typeface="Arial"/>
-              </a:rPr>
-              <a:t>Core Implementation — </a:t>
-            </a:r>
-            <a:r>
-              <a:rPr sz="850">
-                <a:solidFill>
-                  <a:srgbClr val="0F172A"/>
-                </a:solidFill>
-                <a:latin typeface="Arial"/>
-              </a:rPr>
-              <a:t>QuizOperations &amp; QuizEvaluator interfaces, Standard &amp; Negative Marking grading policies.</a:t>
-            </a:r>
-          </a:p>
-          <a:p>
-            <a:pPr>
-              <a:spcAft>
-                <a:spcPts val="300"/>
-              </a:spcAft>
-            </a:pPr>
-            <a:r>
-              <a:rPr b="1" sz="850">
-                <a:solidFill>
-                  <a:srgbClr val="0F172A"/>
-                </a:solidFill>
-                <a:latin typeface="Arial"/>
-              </a:rPr>
-              <a:t>Viva Focus — </a:t>
-            </a:r>
-            <a:r>
-              <a:rPr sz="850">
-                <a:solidFill>
-                  <a:srgbClr val="0F172A"/>
-                </a:solidFill>
-                <a:latin typeface="Arial"/>
-              </a:rPr>
-              <a:t>Why create the QuizEvaluator interface? How does it satisfy the Open/Closed Principle?</a:t>
-            </a:r>
-          </a:p>
-        </p:txBody>
-      </p:sp>
-      <p:sp>
-        <p:nvSpPr>
-          <p:cNvPr id="10" name="Rounded Rectangle 9"/>
-          <p:cNvSpPr/>
-          <p:nvPr/>
-        </p:nvSpPr>
-        <p:spPr>
-          <a:xfrm>
-            <a:off x="6217920" y="3977639"/>
-            <a:ext cx="5212080" cy="2377440"/>
-          </a:xfrm>
-          <a:prstGeom prst="roundRect">
-            <a:avLst/>
-          </a:prstGeom>
-          <a:solidFill>
-            <a:srgbClr val="FFFFFF"/>
-          </a:solidFill>
-          <a:ln w="19050">
-            <a:solidFill>
-              <a:srgbClr val="E2E8F0"/>
-            </a:solidFill>
-          </a:ln>
-        </p:spPr>
-        <p:style>
-          <a:lnRef idx="1">
-            <a:schemeClr val="accent1"/>
-          </a:lnRef>
-          <a:fillRef idx="3">
-            <a:schemeClr val="accent1"/>
-          </a:fillRef>
-          <a:effectRef idx="2">
-            <a:schemeClr val="accent1"/>
-          </a:effectRef>
-          <a:fontRef idx="minor">
-            <a:schemeClr val="lt1"/>
-          </a:fontRef>
-        </p:style>
-        <p:txBody>
-          <a:bodyPr rtlCol="0" anchor="ctr" wrap="square" lIns="182880" rIns="182880" tIns="164592" bIns="164592"/>
-          <a:lstStyle/>
-          <a:p>
-            <a:pPr algn="ctr">
-              <a:spcAft>
-                <a:spcPts val="200"/>
-              </a:spcAft>
-              <a:defRPr sz="850" b="1">
-                <a:solidFill>
-                  <a:srgbClr val="2563EB"/>
-                </a:solidFill>
-                <a:latin typeface="Arial"/>
-              </a:defRPr>
-            </a:pPr>
-            <a:r>
-              <a:t>TEAM MEMBER (IT B)</a:t>
-            </a:r>
-          </a:p>
-          <a:p>
-            <a:pPr>
-              <a:spcAft>
-                <a:spcPts val="400"/>
-              </a:spcAft>
-              <a:defRPr sz="1200" b="1">
-                <a:solidFill>
-                  <a:srgbClr val="1B365D"/>
-                </a:solidFill>
-                <a:latin typeface="Arial"/>
-              </a:defRPr>
-            </a:pPr>
-            <a:r>
-              <a:t>Utkarsh Chauhan (Roll No: 8154)</a:t>
-            </a:r>
-          </a:p>
-          <a:p>
-            <a:pPr>
-              <a:spcAft>
-                <a:spcPts val="300"/>
-              </a:spcAft>
-            </a:pPr>
-            <a:r>
-              <a:rPr b="1" sz="850">
-                <a:solidFill>
-                  <a:srgbClr val="0F172A"/>
-                </a:solidFill>
-                <a:latin typeface="Arial"/>
-              </a:rPr>
-              <a:t>Assigned Role — </a:t>
-            </a:r>
-            <a:r>
-              <a:rPr sz="850">
-                <a:solidFill>
-                  <a:srgbClr val="0F172A"/>
-                </a:solidFill>
-                <a:latin typeface="Arial"/>
-              </a:rPr>
-              <a:t>Quality Assurance &amp; Custom Exception Architect</a:t>
-            </a:r>
-          </a:p>
-          <a:p>
-            <a:pPr>
-              <a:spcAft>
-                <a:spcPts val="300"/>
-              </a:spcAft>
-            </a:pPr>
-            <a:r>
-              <a:rPr b="1" sz="850">
-                <a:solidFill>
-                  <a:srgbClr val="0F172A"/>
-                </a:solidFill>
-                <a:latin typeface="Arial"/>
-              </a:rPr>
-              <a:t>Unit III Allocation — </a:t>
-            </a:r>
-            <a:r>
-              <a:rPr sz="850">
-                <a:solidFill>
-                  <a:srgbClr val="0F172A"/>
-                </a:solidFill>
-                <a:latin typeface="Arial"/>
-              </a:rPr>
-              <a:t>Interface Implementation &amp; Collections Architecture</a:t>
-            </a:r>
-          </a:p>
-          <a:p>
-            <a:pPr>
-              <a:spcAft>
-                <a:spcPts val="300"/>
-              </a:spcAft>
-            </a:pPr>
-            <a:r>
-              <a:rPr b="1" sz="850">
-                <a:solidFill>
-                  <a:srgbClr val="0F172A"/>
-                </a:solidFill>
-                <a:latin typeface="Arial"/>
-              </a:rPr>
-              <a:t>Unit IV Allocation — </a:t>
-            </a:r>
-            <a:r>
-              <a:rPr sz="850">
-                <a:solidFill>
-                  <a:srgbClr val="0F172A"/>
-                </a:solidFill>
-                <a:latin typeface="Arial"/>
-              </a:rPr>
-              <a:t>User-Defined Checked Exceptions &amp; Zero-Crash Input Recovery</a:t>
-            </a:r>
-          </a:p>
-          <a:p>
-            <a:pPr>
-              <a:spcAft>
-                <a:spcPts val="300"/>
-              </a:spcAft>
-            </a:pPr>
-            <a:r>
-              <a:rPr b="1" sz="850">
-                <a:solidFill>
-                  <a:srgbClr val="0F172A"/>
-                </a:solidFill>
-                <a:latin typeface="Arial"/>
-              </a:rPr>
-              <a:t>Core Implementation — </a:t>
-            </a:r>
-            <a:r>
-              <a:rPr sz="850">
-                <a:solidFill>
-                  <a:srgbClr val="0F172A"/>
-                </a:solidFill>
-                <a:latin typeface="Arial"/>
-              </a:rPr>
-              <a:t>QuizManager, 5-tier QuizException tree, defensive InputValidator, and run_tests.bat test suite.</a:t>
-            </a:r>
-          </a:p>
-          <a:p>
-            <a:pPr>
-              <a:spcAft>
-                <a:spcPts val="300"/>
-              </a:spcAft>
-            </a:pPr>
-            <a:r>
-              <a:rPr b="1" sz="850">
-                <a:solidFill>
-                  <a:srgbClr val="0F172A"/>
-                </a:solidFill>
-                <a:latin typeface="Arial"/>
-              </a:rPr>
-              <a:t>Viva Focus — </a:t>
-            </a:r>
-            <a:r>
-              <a:rPr sz="850">
-                <a:solidFill>
-                  <a:srgbClr val="0F172A"/>
-                </a:solidFill>
-                <a:latin typeface="Arial"/>
-              </a:rPr>
-              <a:t>What custom exceptions can occur and how are they handled? Purpose of try-catch-finally?</a:t>
-            </a:r>
-          </a:p>
-        </p:txBody>
-      </p:sp>
-    </p:spTree>
-  </p:cSld>
-  <p:clrMapOvr>
-    <a:masterClrMapping/>
-  </p:clrMapOvr>
-</p:sld>
-</file>
-
-<file path=ppt/slides/slide12.xml><?xml version="1.0" encoding="utf-8"?>
-<p:sld xmlns:a="http://schemas.openxmlformats.org/drawingml/2006/main" xmlns:p="http://schemas.openxmlformats.org/presentationml/2006/main" xmlns:r="http://schemas.openxmlformats.org/officeDocument/2006/relationships">
-  <p:cSld>
-    <p:spTree>
-      <p:nvGrpSpPr>
-        <p:cNvPr id="1" name=""/>
-        <p:cNvGrpSpPr/>
-        <p:nvPr/>
-      </p:nvGrpSpPr>
-      <p:grpSpPr/>
-      <p:sp>
-        <p:nvSpPr>
-          <p:cNvPr id="2" name="Rectangle 1"/>
-          <p:cNvSpPr/>
-          <p:nvPr/>
-        </p:nvSpPr>
-        <p:spPr>
-          <a:xfrm>
-            <a:off x="0" y="0"/>
-            <a:ext cx="12191695" cy="6858000"/>
-          </a:xfrm>
-          <a:prstGeom prst="rect">
-            <a:avLst/>
-          </a:prstGeom>
-          <a:solidFill>
-            <a:srgbClr val="FBF9F4"/>
-          </a:solidFill>
-          <a:ln>
-            <a:noFill/>
-          </a:ln>
-        </p:spPr>
-        <p:style>
-          <a:lnRef idx="1">
-            <a:schemeClr val="accent1"/>
-          </a:lnRef>
-          <a:fillRef idx="3">
-            <a:schemeClr val="accent1"/>
-          </a:fillRef>
-          <a:effectRef idx="2">
-            <a:schemeClr val="accent1"/>
-          </a:effectRef>
-          <a:fontRef idx="minor">
-            <a:schemeClr val="lt1"/>
-          </a:fontRef>
-        </p:style>
-        <p:txBody>
-          <a:bodyPr rtlCol="0" anchor="ctr"/>
-          <a:lstStyle/>
-          <a:p>
-            <a:pPr algn="ctr"/>
-          </a:p>
-        </p:txBody>
-      </p:sp>
-      <p:sp>
-        <p:nvSpPr>
-          <p:cNvPr id="3" name="Rectangle 2"/>
-          <p:cNvSpPr/>
-          <p:nvPr/>
-        </p:nvSpPr>
-        <p:spPr>
-          <a:xfrm>
-            <a:off x="731520" y="365760"/>
-            <a:ext cx="10698480" cy="36576"/>
-          </a:xfrm>
-          <a:prstGeom prst="rect">
-            <a:avLst/>
-          </a:prstGeom>
-          <a:solidFill>
-            <a:srgbClr val="1B365D"/>
-          </a:solidFill>
-          <a:ln>
-            <a:noFill/>
-          </a:ln>
-        </p:spPr>
-        <p:style>
-          <a:lnRef idx="1">
-            <a:schemeClr val="accent1"/>
-          </a:lnRef>
-          <a:fillRef idx="3">
-            <a:schemeClr val="accent1"/>
-          </a:fillRef>
-          <a:effectRef idx="2">
-            <a:schemeClr val="accent1"/>
-          </a:effectRef>
-          <a:fontRef idx="minor">
-            <a:schemeClr val="lt1"/>
-          </a:fontRef>
-        </p:style>
-        <p:txBody>
-          <a:bodyPr rtlCol="0" anchor="ctr"/>
-          <a:lstStyle/>
-          <a:p>
-            <a:pPr algn="ctr"/>
-          </a:p>
-        </p:txBody>
-      </p:sp>
-      <p:sp>
-        <p:nvSpPr>
-          <p:cNvPr id="4" name="TextBox 3"/>
-          <p:cNvSpPr txBox="1"/>
-          <p:nvPr/>
-        </p:nvSpPr>
-        <p:spPr>
-          <a:xfrm>
-            <a:off x="731520" y="411480"/>
-            <a:ext cx="9326880" cy="822960"/>
-          </a:xfrm>
-          <a:prstGeom prst="rect">
-            <a:avLst/>
-          </a:prstGeom>
-          <a:noFill/>
-        </p:spPr>
-        <p:txBody>
-          <a:bodyPr wrap="square" lIns="0" tIns="0" rIns="0" bIns="0">
-            <a:spAutoFit/>
-          </a:bodyPr>
-          <a:lstStyle/>
-          <a:p>
-            <a:pPr>
-              <a:defRPr sz="2200" b="1">
-                <a:solidFill>
-                  <a:srgbClr val="1B365D"/>
-                </a:solidFill>
-                <a:latin typeface="Arial"/>
-              </a:defRPr>
-            </a:pPr>
-            <a:r>
-              <a:t>TEAMMATE DEFENSE: ADITYA YADAV (ROLL: 8108)</a:t>
-            </a:r>
-          </a:p>
-          <a:p>
-            <a:pPr>
-              <a:defRPr sz="1100" b="1">
-                <a:solidFill>
-                  <a:srgbClr val="EA580C"/>
-                </a:solidFill>
-                <a:latin typeface="Arial"/>
-              </a:defRPr>
-            </a:pPr>
-            <a:r>
-              <a:t>SE IT B • ASSIGNED ROLE: GROUP LEADER &amp; SYSTEM ARCHITECT • UNIT III &amp; IV TOPIC DEEP DIVE</a:t>
-            </a:r>
-          </a:p>
-        </p:txBody>
-      </p:sp>
-      <p:pic>
-        <p:nvPicPr>
-          <p:cNvPr id="5" name="Picture 4" descr="ait_official_badge.png"/>
-          <p:cNvPicPr>
-            <a:picLocks noChangeAspect="1"/>
-          </p:cNvPicPr>
-          <p:nvPr/>
-        </p:nvPicPr>
-        <p:blipFill>
-          <a:blip r:embed="rId2"/>
-          <a:stretch>
-            <a:fillRect/>
-          </a:stretch>
-        </p:blipFill>
-        <p:spPr>
-          <a:xfrm>
-            <a:off x="10789920" y="320040"/>
-            <a:ext cx="868680" cy="868680"/>
-          </a:xfrm>
-          <a:prstGeom prst="rect">
-            <a:avLst/>
-          </a:prstGeom>
-        </p:spPr>
-      </p:pic>
-      <p:sp>
-        <p:nvSpPr>
-          <p:cNvPr id="6" name="TextBox 5"/>
-          <p:cNvSpPr txBox="1"/>
-          <p:nvPr/>
-        </p:nvSpPr>
-        <p:spPr>
-          <a:xfrm>
-            <a:off x="11155680" y="6400800"/>
-            <a:ext cx="731520" cy="365760"/>
-          </a:xfrm>
-          <a:prstGeom prst="rect">
-            <a:avLst/>
-          </a:prstGeom>
-          <a:noFill/>
-        </p:spPr>
-        <p:txBody>
-          <a:bodyPr wrap="none">
-            <a:spAutoFit/>
-          </a:bodyPr>
-          <a:lstStyle/>
-          <a:p>
-            <a:pPr>
-              <a:defRPr sz="1200">
-                <a:solidFill>
-                  <a:srgbClr val="64748B"/>
-                </a:solidFill>
-                <a:latin typeface="Arial"/>
-              </a:defRPr>
-            </a:pPr>
-            <a:r>
-              <a:t>12</a:t>
-            </a:r>
-          </a:p>
-        </p:txBody>
-      </p:sp>
-      <p:sp>
-        <p:nvSpPr>
-          <p:cNvPr id="7" name="Rounded Rectangle 6"/>
-          <p:cNvSpPr/>
-          <p:nvPr/>
-        </p:nvSpPr>
-        <p:spPr>
-          <a:xfrm>
-            <a:off x="731520" y="1371600"/>
-            <a:ext cx="10728655" cy="685800"/>
-          </a:xfrm>
-          <a:prstGeom prst="roundRect">
-            <a:avLst/>
-          </a:prstGeom>
-          <a:solidFill>
-            <a:srgbClr val="1E293B"/>
-          </a:solidFill>
-          <a:ln w="19050">
-            <a:solidFill>
-              <a:srgbClr val="2563EB"/>
-            </a:solidFill>
-          </a:ln>
-        </p:spPr>
-        <p:style>
-          <a:lnRef idx="1">
-            <a:schemeClr val="accent1"/>
-          </a:lnRef>
-          <a:fillRef idx="3">
-            <a:schemeClr val="accent1"/>
-          </a:fillRef>
-          <a:effectRef idx="2">
-            <a:schemeClr val="accent1"/>
-          </a:effectRef>
-          <a:fontRef idx="minor">
-            <a:schemeClr val="lt1"/>
-          </a:fontRef>
-        </p:style>
-        <p:txBody>
-          <a:bodyPr rtlCol="0" anchor="ctr" wrap="square" lIns="228600" rIns="228600" tIns="109728"/>
-          <a:lstStyle/>
-          <a:p>
-            <a:pPr algn="ctr"/>
-            <a:r>
-              <a:rPr b="1" sz="1300">
-                <a:solidFill>
-                  <a:srgbClr val="FFFFFF"/>
-                </a:solidFill>
-              </a:rPr>
-              <a:t>STUDENT: Aditya Yadav  </a:t>
-            </a:r>
-            <a:r>
-              <a:rPr b="1" sz="1100">
-                <a:solidFill>
-                  <a:srgbClr val="EA580C"/>
-                </a:solidFill>
-              </a:rPr>
-              <a:t>•  ROLL NO: 8108  •  CLASS: SE IT B  •  </a:t>
-            </a:r>
-            <a:r>
-              <a:rPr b="1" sz="1100">
-                <a:solidFill>
-                  <a:srgbClr val="2563EB"/>
-                </a:solidFill>
-              </a:rPr>
-              <a:t>ROLE: Group Leader &amp; System Architect  •  SPPU BIT25434A0X (CO3, CO4)</a:t>
-            </a:r>
-          </a:p>
-        </p:txBody>
-      </p:sp>
-      <p:sp>
-        <p:nvSpPr>
-          <p:cNvPr id="8" name="Rounded Rectangle 7"/>
-          <p:cNvSpPr/>
-          <p:nvPr/>
-        </p:nvSpPr>
-        <p:spPr>
-          <a:xfrm>
-            <a:off x="731520" y="2148840"/>
-            <a:ext cx="5257800" cy="4389120"/>
-          </a:xfrm>
-          <a:prstGeom prst="roundRect">
-            <a:avLst/>
-          </a:prstGeom>
-          <a:solidFill>
-            <a:srgbClr val="FFFFFF"/>
-          </a:solidFill>
-          <a:ln w="19050">
-            <a:solidFill>
-              <a:srgbClr val="2563EB"/>
-            </a:solidFill>
-          </a:ln>
-        </p:spPr>
-        <p:style>
-          <a:lnRef idx="1">
-            <a:schemeClr val="accent1"/>
-          </a:lnRef>
-          <a:fillRef idx="3">
-            <a:schemeClr val="accent1"/>
-          </a:fillRef>
-          <a:effectRef idx="2">
-            <a:schemeClr val="accent1"/>
-          </a:effectRef>
-          <a:fontRef idx="minor">
-            <a:schemeClr val="lt1"/>
-          </a:fontRef>
-        </p:style>
-        <p:txBody>
-          <a:bodyPr rtlCol="0" anchor="ctr" wrap="square" lIns="182880" rIns="182880" tIns="164592" bIns="164592"/>
-          <a:lstStyle/>
-          <a:p>
-            <a:pPr algn="ctr">
-              <a:spcAft>
-                <a:spcPts val="200"/>
-              </a:spcAft>
-              <a:defRPr sz="850" b="1">
-                <a:solidFill>
-                  <a:srgbClr val="2563EB"/>
-                </a:solidFill>
-                <a:latin typeface="Arial"/>
-              </a:defRPr>
-            </a:pPr>
-            <a:r>
-              <a:t>UNIT III: POLYMORPHISM &amp; INTERFACES</a:t>
-            </a:r>
-          </a:p>
-          <a:p>
-            <a:pPr>
-              <a:spcAft>
-                <a:spcPts val="400"/>
-              </a:spcAft>
-              <a:defRPr sz="1200" b="1">
-                <a:solidFill>
-                  <a:srgbClr val="1B365D"/>
-                </a:solidFill>
-                <a:latin typeface="Arial"/>
-              </a:defRPr>
-            </a:pPr>
-            <a:r>
-              <a:t>Unit III: Abstract Classes &amp; Pure Abstract Methods</a:t>
-            </a:r>
-          </a:p>
-          <a:p>
-            <a:pPr>
-              <a:spcAft>
-                <a:spcPts val="300"/>
-              </a:spcAft>
-            </a:pPr>
-            <a:r>
-              <a:rPr b="1" sz="850">
-                <a:solidFill>
-                  <a:srgbClr val="0F172A"/>
-                </a:solidFill>
-                <a:latin typeface="Arial"/>
-              </a:rPr>
-              <a:t>Syllabus Topic &amp; Definition — </a:t>
-            </a:r>
-            <a:r>
-              <a:rPr sz="850">
-                <a:solidFill>
-                  <a:srgbClr val="0F172A"/>
-                </a:solidFill>
-                <a:latin typeface="Arial"/>
-              </a:rPr>
-              <a:t>Abstract Classes and Methods (SPPU Unit III). An abstract class cannot be instantiated directly with 'new'; it defines a shared structural contract containing both implemented state/methods and pure abstract method signatures that derived classes must override.</a:t>
-            </a:r>
-          </a:p>
-          <a:p>
-            <a:pPr>
-              <a:spcAft>
-                <a:spcPts val="300"/>
-              </a:spcAft>
-            </a:pPr>
-            <a:r>
-              <a:rPr b="1" sz="850">
-                <a:solidFill>
-                  <a:srgbClr val="0F172A"/>
-                </a:solidFill>
-                <a:latin typeface="Arial"/>
-              </a:rPr>
-              <a:t>Why Used in Architecture — </a:t>
-            </a:r>
-            <a:r>
-              <a:rPr sz="850">
-                <a:solidFill>
-                  <a:srgbClr val="0F172A"/>
-                </a:solidFill>
-                <a:latin typeface="Arial"/>
-              </a:rPr>
-              <a:t>A generic 'Question' or 'User' does not exist in isolation without specialized choice or role behavior. Declaring them abstract prevents naked instantiation while allowing shared state reuse (id, marks, topic, user identity).</a:t>
-            </a:r>
-          </a:p>
-          <a:p>
-            <a:pPr>
-              <a:spcAft>
-                <a:spcPts val="300"/>
-              </a:spcAft>
-            </a:pPr>
-            <a:r>
-              <a:rPr b="1" sz="850">
-                <a:solidFill>
-                  <a:srgbClr val="0F172A"/>
-                </a:solidFill>
-                <a:latin typeface="Arial"/>
-              </a:rPr>
-              <a:t>Project Implementation — </a:t>
-            </a:r>
-            <a:r>
-              <a:rPr sz="850">
-                <a:solidFill>
-                  <a:srgbClr val="0F172A"/>
-                </a:solidFill>
-                <a:latin typeface="Arial"/>
-              </a:rPr>
-              <a:t>Architected abstract class Question (fields: id, questionText, marks, topic, difficulty) with pure abstract signatures: displayQuestion(), checkAnswer(String) throws InvalidOptionException, and getCorrectAnswerFormatted(). Created abstract class User with abstract void displayDashboard().</a:t>
-            </a:r>
-          </a:p>
-          <a:p>
-            <a:pPr>
-              <a:spcAft>
-                <a:spcPts val="300"/>
-              </a:spcAft>
-            </a:pPr>
-            <a:r>
-              <a:rPr b="1" sz="850">
-                <a:solidFill>
-                  <a:srgbClr val="0F172A"/>
-                </a:solidFill>
-                <a:latin typeface="Arial"/>
-              </a:rPr>
-              <a:t>Code Snippet — </a:t>
-            </a:r>
-            <a:r>
-              <a:rPr sz="850">
-                <a:solidFill>
-                  <a:srgbClr val="0F172A"/>
-                </a:solidFill>
-                <a:latin typeface="Arial"/>
-              </a:rPr>
-              <a:t>public abstract class Question {
-    protected String id, questionText, topic; protected int marks;
-    public abstract void displayQuestion();
-    public abstract boolean checkAnswer(String s) throws InvalidOptionException;
-}</a:t>
-            </a:r>
-          </a:p>
-          <a:p>
-            <a:pPr>
-              <a:spcAft>
-                <a:spcPts val="300"/>
-              </a:spcAft>
-            </a:pPr>
-            <a:r>
-              <a:rPr b="1" sz="850">
-                <a:solidFill>
-                  <a:srgbClr val="0F172A"/>
-                </a:solidFill>
-                <a:latin typeface="Arial"/>
-              </a:rPr>
-              <a:t>Viva Defense (Rubric Answer) — </a:t>
-            </a:r>
-            <a:r>
-              <a:rPr sz="850">
-                <a:solidFill>
-                  <a:srgbClr val="0F172A"/>
-                </a:solidFill>
-                <a:latin typeface="Arial"/>
-              </a:rPr>
-              <a:t>Q: Why use an abstract class instead of an interface here?
-A: Because all questions share persistent state (fields: id, marks, topic) and concrete helper logic (displayHeader()). Interfaces cannot declare mutable instance state or constructors.</a:t>
-            </a:r>
-          </a:p>
-        </p:txBody>
-      </p:sp>
-      <p:sp>
-        <p:nvSpPr>
-          <p:cNvPr id="9" name="Rounded Rectangle 8"/>
-          <p:cNvSpPr/>
-          <p:nvPr/>
-        </p:nvSpPr>
-        <p:spPr>
-          <a:xfrm>
-            <a:off x="6199632" y="2148840"/>
-            <a:ext cx="5257800" cy="4389120"/>
-          </a:xfrm>
-          <a:prstGeom prst="roundRect">
-            <a:avLst/>
-          </a:prstGeom>
-          <a:solidFill>
-            <a:srgbClr val="FFFFFF"/>
-          </a:solidFill>
-          <a:ln w="19050">
-            <a:solidFill>
-              <a:srgbClr val="EA580C"/>
-            </a:solidFill>
-          </a:ln>
-        </p:spPr>
-        <p:style>
-          <a:lnRef idx="1">
-            <a:schemeClr val="accent1"/>
-          </a:lnRef>
-          <a:fillRef idx="3">
-            <a:schemeClr val="accent1"/>
-          </a:fillRef>
-          <a:effectRef idx="2">
-            <a:schemeClr val="accent1"/>
-          </a:effectRef>
-          <a:fontRef idx="minor">
-            <a:schemeClr val="lt1"/>
-          </a:fontRef>
-        </p:style>
-        <p:txBody>
-          <a:bodyPr rtlCol="0" anchor="ctr" wrap="square" lIns="182880" rIns="182880" tIns="164592" bIns="164592"/>
-          <a:lstStyle/>
-          <a:p>
-            <a:pPr algn="ctr">
-              <a:spcAft>
-                <a:spcPts val="200"/>
-              </a:spcAft>
-              <a:defRPr sz="850" b="1">
-                <a:solidFill>
-                  <a:srgbClr val="2563EB"/>
-                </a:solidFill>
-                <a:latin typeface="Arial"/>
-              </a:defRPr>
-            </a:pPr>
-            <a:r>
-              <a:t>UNIT IV: ERROR &amp; EXCEPTION HANDLING</a:t>
-            </a:r>
-          </a:p>
-          <a:p>
-            <a:pPr>
-              <a:spcAft>
-                <a:spcPts val="400"/>
-              </a:spcAft>
-              <a:defRPr sz="1200" b="1">
-                <a:solidFill>
-                  <a:srgbClr val="1B365D"/>
-                </a:solidFill>
-                <a:latin typeface="Arial"/>
-              </a:defRPr>
-            </a:pPr>
-            <a:r>
-              <a:t>Unit IV: Types of Errors &amp; Parameter Boundary Validation</a:t>
-            </a:r>
-          </a:p>
-          <a:p>
-            <a:pPr>
-              <a:spcAft>
-                <a:spcPts val="300"/>
-              </a:spcAft>
-            </a:pPr>
-            <a:r>
-              <a:rPr b="1" sz="850">
-                <a:solidFill>
-                  <a:srgbClr val="0F172A"/>
-                </a:solidFill>
-                <a:latin typeface="Arial"/>
-              </a:rPr>
-              <a:t>Syllabus Topic &amp; Definition — </a:t>
-            </a:r>
-            <a:r>
-              <a:rPr sz="850">
-                <a:solidFill>
-                  <a:srgbClr val="0F172A"/>
-                </a:solidFill>
-                <a:latin typeface="Arial"/>
-              </a:rPr>
-              <a:t>Types of Error (SPPU Unit IV). Errors are categorized into: (1) Compile-time / Syntax errors caught by javac, (2) Logical errors (faulty algorithms resulting in wrong calculations), and (3) Runtime errors/exceptions (abnormal conditions during JVM execution).</a:t>
-            </a:r>
-          </a:p>
-          <a:p>
-            <a:pPr>
-              <a:spcAft>
-                <a:spcPts val="300"/>
-              </a:spcAft>
-            </a:pPr>
-            <a:r>
-              <a:rPr b="1" sz="850">
-                <a:solidFill>
-                  <a:srgbClr val="0F172A"/>
-                </a:solidFill>
-                <a:latin typeface="Arial"/>
-              </a:rPr>
-              <a:t>Operational Failure &amp; Mitigation — </a:t>
-            </a:r>
-            <a:r>
-              <a:rPr sz="850">
-                <a:solidFill>
-                  <a:srgbClr val="0F172A"/>
-                </a:solidFill>
-                <a:latin typeface="Arial"/>
-              </a:rPr>
-              <a:t>Unchecked question creation could allow negative marks, zero-question quizzes, or empty IDs, corrupting database state and causing division-by-zero during percentage calculation.</a:t>
-            </a:r>
-          </a:p>
-          <a:p>
-            <a:pPr>
-              <a:spcAft>
-                <a:spcPts val="300"/>
-              </a:spcAft>
-            </a:pPr>
-            <a:r>
-              <a:rPr b="1" sz="850">
-                <a:solidFill>
-                  <a:srgbClr val="0F172A"/>
-                </a:solidFill>
-                <a:latin typeface="Arial"/>
-              </a:rPr>
-              <a:t>Project Implementation — </a:t>
-            </a:r>
-            <a:r>
-              <a:rPr sz="850">
-                <a:solidFill>
-                  <a:srgbClr val="0F172A"/>
-                </a:solidFill>
-                <a:latin typeface="Arial"/>
-              </a:rPr>
-              <a:t>Enforced defensive constructor parameter checking in Question and Quiz entities. Throws checked InvalidQuestionException if marks &lt;= 0 or id is blank, and EmptyQuizException if conducting a quiz with 0 questions.</a:t>
-            </a:r>
-          </a:p>
-          <a:p>
-            <a:pPr>
-              <a:spcAft>
-                <a:spcPts val="300"/>
-              </a:spcAft>
-            </a:pPr>
-            <a:r>
-              <a:rPr b="1" sz="850">
-                <a:solidFill>
-                  <a:srgbClr val="0F172A"/>
-                </a:solidFill>
-                <a:latin typeface="Arial"/>
-              </a:rPr>
-              <a:t>Code Snippet — </a:t>
-            </a:r>
-            <a:r>
-              <a:rPr sz="850">
-                <a:solidFill>
-                  <a:srgbClr val="0F172A"/>
-                </a:solidFill>
-                <a:latin typeface="Arial"/>
-              </a:rPr>
-              <a:t>if (marks &lt;= 0) throw new InvalidQuestionException("Marks must be &gt; 0: " + marks);
-if (id == null || id.trim().isEmpty()) throw new InvalidQuestionException("ID empty");</a:t>
-            </a:r>
-          </a:p>
-          <a:p>
-            <a:pPr>
-              <a:spcAft>
-                <a:spcPts val="300"/>
-              </a:spcAft>
-            </a:pPr>
-            <a:r>
-              <a:rPr b="1" sz="850">
-                <a:solidFill>
-                  <a:srgbClr val="0F172A"/>
-                </a:solidFill>
-                <a:latin typeface="Arial"/>
-              </a:rPr>
-              <a:t>Viva Defense (Rubric Answer) — </a:t>
-            </a:r>
-            <a:r>
-              <a:rPr sz="850">
-                <a:solidFill>
-                  <a:srgbClr val="0F172A"/>
-                </a:solidFill>
-                <a:latin typeface="Arial"/>
-              </a:rPr>
-              <a:t>Q: How does defensive validation prevent runtime errors in your project?
-A: By enforcing strict preconditions in entity constructors, invalid state is intercepted at creation time, preventing downstream NullPointerExceptions and scoring calculation crashes.</a:t>
-            </a:r>
-          </a:p>
-        </p:txBody>
-      </p:sp>
-    </p:spTree>
-  </p:cSld>
-  <p:clrMapOvr>
-    <a:masterClrMapping/>
-  </p:clrMapOvr>
-</p:sld>
-</file>
-
-<file path=ppt/slides/slide13.xml><?xml version="1.0" encoding="utf-8"?>
-<p:sld xmlns:a="http://schemas.openxmlformats.org/drawingml/2006/main" xmlns:p="http://schemas.openxmlformats.org/presentationml/2006/main" xmlns:r="http://schemas.openxmlformats.org/officeDocument/2006/relationships">
-  <p:cSld>
-    <p:spTree>
-      <p:nvGrpSpPr>
-        <p:cNvPr id="1" name=""/>
-        <p:cNvGrpSpPr/>
-        <p:nvPr/>
-      </p:nvGrpSpPr>
-      <p:grpSpPr/>
-      <p:sp>
-        <p:nvSpPr>
-          <p:cNvPr id="2" name="Rectangle 1"/>
-          <p:cNvSpPr/>
-          <p:nvPr/>
-        </p:nvSpPr>
-        <p:spPr>
-          <a:xfrm>
-            <a:off x="0" y="0"/>
-            <a:ext cx="12191695" cy="6858000"/>
-          </a:xfrm>
-          <a:prstGeom prst="rect">
-            <a:avLst/>
-          </a:prstGeom>
-          <a:solidFill>
-            <a:srgbClr val="FBF9F4"/>
-          </a:solidFill>
-          <a:ln>
-            <a:noFill/>
-          </a:ln>
-        </p:spPr>
-        <p:style>
-          <a:lnRef idx="1">
-            <a:schemeClr val="accent1"/>
-          </a:lnRef>
-          <a:fillRef idx="3">
-            <a:schemeClr val="accent1"/>
-          </a:fillRef>
-          <a:effectRef idx="2">
-            <a:schemeClr val="accent1"/>
-          </a:effectRef>
-          <a:fontRef idx="minor">
-            <a:schemeClr val="lt1"/>
-          </a:fontRef>
-        </p:style>
-        <p:txBody>
-          <a:bodyPr rtlCol="0" anchor="ctr"/>
-          <a:lstStyle/>
-          <a:p>
-            <a:pPr algn="ctr"/>
-          </a:p>
-        </p:txBody>
-      </p:sp>
-      <p:sp>
-        <p:nvSpPr>
-          <p:cNvPr id="3" name="Rectangle 2"/>
-          <p:cNvSpPr/>
-          <p:nvPr/>
-        </p:nvSpPr>
-        <p:spPr>
-          <a:xfrm>
-            <a:off x="731520" y="365760"/>
-            <a:ext cx="10698480" cy="36576"/>
-          </a:xfrm>
-          <a:prstGeom prst="rect">
-            <a:avLst/>
-          </a:prstGeom>
-          <a:solidFill>
-            <a:srgbClr val="1B365D"/>
-          </a:solidFill>
-          <a:ln>
-            <a:noFill/>
-          </a:ln>
-        </p:spPr>
-        <p:style>
-          <a:lnRef idx="1">
-            <a:schemeClr val="accent1"/>
-          </a:lnRef>
-          <a:fillRef idx="3">
-            <a:schemeClr val="accent1"/>
-          </a:fillRef>
-          <a:effectRef idx="2">
-            <a:schemeClr val="accent1"/>
-          </a:effectRef>
-          <a:fontRef idx="minor">
-            <a:schemeClr val="lt1"/>
-          </a:fontRef>
-        </p:style>
-        <p:txBody>
-          <a:bodyPr rtlCol="0" anchor="ctr"/>
-          <a:lstStyle/>
-          <a:p>
-            <a:pPr algn="ctr"/>
-          </a:p>
-        </p:txBody>
-      </p:sp>
-      <p:sp>
-        <p:nvSpPr>
-          <p:cNvPr id="4" name="TextBox 3"/>
-          <p:cNvSpPr txBox="1"/>
-          <p:nvPr/>
-        </p:nvSpPr>
-        <p:spPr>
-          <a:xfrm>
-            <a:off x="731520" y="411480"/>
-            <a:ext cx="9326880" cy="822960"/>
-          </a:xfrm>
-          <a:prstGeom prst="rect">
-            <a:avLst/>
-          </a:prstGeom>
-          <a:noFill/>
-        </p:spPr>
-        <p:txBody>
-          <a:bodyPr wrap="square" lIns="0" tIns="0" rIns="0" bIns="0">
-            <a:spAutoFit/>
-          </a:bodyPr>
-          <a:lstStyle/>
-          <a:p>
-            <a:pPr>
-              <a:defRPr sz="2200" b="1">
-                <a:solidFill>
-                  <a:srgbClr val="1B365D"/>
-                </a:solidFill>
-                <a:latin typeface="Arial"/>
-              </a:defRPr>
-            </a:pPr>
-            <a:r>
-              <a:t>TEAMMATE DEFENSE: ABHISHEKH SINGH (ROLL: 8104)</a:t>
-            </a:r>
-          </a:p>
-          <a:p>
-            <a:pPr>
-              <a:defRPr sz="1100" b="1">
-                <a:solidFill>
-                  <a:srgbClr val="EA580C"/>
-                </a:solidFill>
-                <a:latin typeface="Arial"/>
-              </a:defRPr>
-            </a:pPr>
-            <a:r>
-              <a:t>SE IT B • ASSIGNED ROLE: POLYMORPHIC QUESTION SPECIALIST &amp; CORE DEV • UNIT III &amp; IV TOPIC DEEP DIVE</a:t>
-            </a:r>
-          </a:p>
-        </p:txBody>
-      </p:sp>
-      <p:pic>
-        <p:nvPicPr>
-          <p:cNvPr id="5" name="Picture 4" descr="ait_official_badge.png"/>
-          <p:cNvPicPr>
-            <a:picLocks noChangeAspect="1"/>
-          </p:cNvPicPr>
-          <p:nvPr/>
-        </p:nvPicPr>
-        <p:blipFill>
-          <a:blip r:embed="rId2"/>
-          <a:stretch>
-            <a:fillRect/>
-          </a:stretch>
-        </p:blipFill>
-        <p:spPr>
-          <a:xfrm>
-            <a:off x="10789920" y="320040"/>
-            <a:ext cx="868680" cy="868680"/>
-          </a:xfrm>
-          <a:prstGeom prst="rect">
-            <a:avLst/>
-          </a:prstGeom>
-        </p:spPr>
-      </p:pic>
-      <p:sp>
-        <p:nvSpPr>
-          <p:cNvPr id="6" name="TextBox 5"/>
-          <p:cNvSpPr txBox="1"/>
-          <p:nvPr/>
-        </p:nvSpPr>
-        <p:spPr>
-          <a:xfrm>
-            <a:off x="11155680" y="6400800"/>
-            <a:ext cx="731520" cy="365760"/>
-          </a:xfrm>
-          <a:prstGeom prst="rect">
-            <a:avLst/>
-          </a:prstGeom>
-          <a:noFill/>
-        </p:spPr>
-        <p:txBody>
-          <a:bodyPr wrap="none">
-            <a:spAutoFit/>
-          </a:bodyPr>
-          <a:lstStyle/>
-          <a:p>
-            <a:pPr>
-              <a:defRPr sz="1200">
-                <a:solidFill>
-                  <a:srgbClr val="64748B"/>
-                </a:solidFill>
-                <a:latin typeface="Arial"/>
-              </a:defRPr>
-            </a:pPr>
-            <a:r>
-              <a:t>13</a:t>
-            </a:r>
-          </a:p>
-        </p:txBody>
-      </p:sp>
-      <p:sp>
-        <p:nvSpPr>
-          <p:cNvPr id="7" name="Rounded Rectangle 6"/>
-          <p:cNvSpPr/>
-          <p:nvPr/>
-        </p:nvSpPr>
-        <p:spPr>
-          <a:xfrm>
-            <a:off x="731520" y="1371600"/>
-            <a:ext cx="10728655" cy="685800"/>
-          </a:xfrm>
-          <a:prstGeom prst="roundRect">
-            <a:avLst/>
-          </a:prstGeom>
-          <a:solidFill>
-            <a:srgbClr val="1E293B"/>
-          </a:solidFill>
-          <a:ln w="19050">
-            <a:solidFill>
-              <a:srgbClr val="EA580C"/>
-            </a:solidFill>
-          </a:ln>
-        </p:spPr>
-        <p:style>
-          <a:lnRef idx="1">
-            <a:schemeClr val="accent1"/>
-          </a:lnRef>
-          <a:fillRef idx="3">
-            <a:schemeClr val="accent1"/>
-          </a:fillRef>
-          <a:effectRef idx="2">
-            <a:schemeClr val="accent1"/>
-          </a:effectRef>
-          <a:fontRef idx="minor">
-            <a:schemeClr val="lt1"/>
-          </a:fontRef>
-        </p:style>
-        <p:txBody>
-          <a:bodyPr rtlCol="0" anchor="ctr" wrap="square" lIns="228600" rIns="228600" tIns="109728"/>
-          <a:lstStyle/>
-          <a:p>
-            <a:pPr algn="ctr"/>
-            <a:r>
-              <a:rPr b="1" sz="1300">
-                <a:solidFill>
-                  <a:srgbClr val="FFFFFF"/>
-                </a:solidFill>
-              </a:rPr>
-              <a:t>STUDENT: Abhishekh Singh  </a:t>
-            </a:r>
-            <a:r>
-              <a:rPr b="1" sz="1100">
-                <a:solidFill>
-                  <a:srgbClr val="EA580C"/>
-                </a:solidFill>
-              </a:rPr>
-              <a:t>•  ROLL NO: 8104  •  CLASS: SE IT B  •  </a:t>
-            </a:r>
-            <a:r>
-              <a:rPr b="1" sz="1100">
-                <a:solidFill>
-                  <a:srgbClr val="EA580C"/>
-                </a:solidFill>
-              </a:rPr>
-              <a:t>ROLE: Polymorphic Question Specialist &amp; Core Dev  •  SPPU BIT25434A0X (CO3, CO4)</a:t>
-            </a:r>
-          </a:p>
-        </p:txBody>
-      </p:sp>
-      <p:sp>
-        <p:nvSpPr>
-          <p:cNvPr id="8" name="Rounded Rectangle 7"/>
-          <p:cNvSpPr/>
-          <p:nvPr/>
-        </p:nvSpPr>
-        <p:spPr>
-          <a:xfrm>
-            <a:off x="731520" y="2148840"/>
-            <a:ext cx="5257800" cy="4389120"/>
-          </a:xfrm>
-          <a:prstGeom prst="roundRect">
-            <a:avLst/>
-          </a:prstGeom>
-          <a:solidFill>
-            <a:srgbClr val="FFFFFF"/>
-          </a:solidFill>
-          <a:ln w="19050">
-            <a:solidFill>
-              <a:srgbClr val="2563EB"/>
-            </a:solidFill>
-          </a:ln>
-        </p:spPr>
-        <p:style>
-          <a:lnRef idx="1">
-            <a:schemeClr val="accent1"/>
-          </a:lnRef>
-          <a:fillRef idx="3">
-            <a:schemeClr val="accent1"/>
-          </a:fillRef>
-          <a:effectRef idx="2">
-            <a:schemeClr val="accent1"/>
-          </a:effectRef>
-          <a:fontRef idx="minor">
-            <a:schemeClr val="lt1"/>
-          </a:fontRef>
-        </p:style>
-        <p:txBody>
-          <a:bodyPr rtlCol="0" anchor="ctr" wrap="square" lIns="182880" rIns="182880" tIns="164592" bIns="164592"/>
-          <a:lstStyle/>
-          <a:p>
-            <a:pPr algn="ctr">
-              <a:spcAft>
-                <a:spcPts val="200"/>
-              </a:spcAft>
-              <a:defRPr sz="850" b="1">
-                <a:solidFill>
-                  <a:srgbClr val="2563EB"/>
-                </a:solidFill>
-                <a:latin typeface="Arial"/>
-              </a:defRPr>
-            </a:pPr>
-            <a:r>
-              <a:t>UNIT III: POLYMORPHISM &amp; INTERFACES</a:t>
-            </a:r>
-          </a:p>
-          <a:p>
-            <a:pPr>
-              <a:spcAft>
-                <a:spcPts val="400"/>
-              </a:spcAft>
-              <a:defRPr sz="1200" b="1">
-                <a:solidFill>
-                  <a:srgbClr val="1B365D"/>
-                </a:solidFill>
-                <a:latin typeface="Arial"/>
-              </a:defRPr>
-            </a:pPr>
-            <a:r>
-              <a:t>Unit III: Polymorphism, Method Overriding &amp; Dynamic Binding</a:t>
-            </a:r>
-          </a:p>
-          <a:p>
-            <a:pPr>
-              <a:spcAft>
-                <a:spcPts val="300"/>
-              </a:spcAft>
-            </a:pPr>
-            <a:r>
-              <a:rPr b="1" sz="850">
-                <a:solidFill>
-                  <a:srgbClr val="0F172A"/>
-                </a:solidFill>
-                <a:latin typeface="Arial"/>
-              </a:rPr>
-              <a:t>Syllabus Topic &amp; Definition — </a:t>
-            </a:r>
-            <a:r>
-              <a:rPr sz="850">
-                <a:solidFill>
-                  <a:srgbClr val="0F172A"/>
-                </a:solidFill>
-                <a:latin typeface="Arial"/>
-              </a:rPr>
-              <a:t>Polymorphism, Method Overriding &amp; Dynamic Binding (SPPU Unit III). Runtime polymorphism enables an overridden method to be resolved dynamically at execution time via the JVM Virtual Method Table (vtable) based on the actual object instance rather than the reference type.</a:t>
-            </a:r>
-          </a:p>
-          <a:p>
-            <a:pPr>
-              <a:spcAft>
-                <a:spcPts val="300"/>
-              </a:spcAft>
-            </a:pPr>
-            <a:r>
-              <a:rPr b="1" sz="850">
-                <a:solidFill>
-                  <a:srgbClr val="0F172A"/>
-                </a:solidFill>
-                <a:latin typeface="Arial"/>
-              </a:rPr>
-              <a:t>Why Used in Architecture — </a:t>
-            </a:r>
-            <a:r>
-              <a:rPr sz="850">
-                <a:solidFill>
-                  <a:srgbClr val="0F172A"/>
-                </a:solidFill>
-                <a:latin typeface="Arial"/>
-              </a:rPr>
-              <a:t>Allows the central QuizRunner engine to iterate through a heterogeneous list of questions without knowing their concrete types. Adding new question types requires zero modifications to the examination engine.</a:t>
-            </a:r>
-          </a:p>
-          <a:p>
-            <a:pPr>
-              <a:spcAft>
-                <a:spcPts val="300"/>
-              </a:spcAft>
-            </a:pPr>
-            <a:r>
-              <a:rPr b="1" sz="850">
-                <a:solidFill>
-                  <a:srgbClr val="0F172A"/>
-                </a:solidFill>
-                <a:latin typeface="Arial"/>
-              </a:rPr>
-              <a:t>Project Implementation — </a:t>
-            </a:r>
-            <a:r>
-              <a:rPr sz="850">
-                <a:solidFill>
-                  <a:srgbClr val="0F172A"/>
-                </a:solidFill>
-                <a:latin typeface="Arial"/>
-              </a:rPr>
-              <a:t>Extended Question into 3 polymorphic archetypes: (1) MultipleChoiceQuestion (A-D choices &amp; index validation), (2) TrueFalseQuestion (binary T/F parsing), (3) NumericQuestion (floating-point tolerance delta: |actual - expected| &lt;= delta). Built overloaded searchQuiz(topic) and searchQuiz(topic, level).</a:t>
-            </a:r>
-          </a:p>
-          <a:p>
-            <a:pPr>
-              <a:spcAft>
-                <a:spcPts val="300"/>
-              </a:spcAft>
-            </a:pPr>
-            <a:r>
-              <a:rPr b="1" sz="850">
-                <a:solidFill>
-                  <a:srgbClr val="0F172A"/>
-                </a:solidFill>
-                <a:latin typeface="Arial"/>
-              </a:rPr>
-              <a:t>Code Snippet — </a:t>
-            </a:r>
-            <a:r>
-              <a:rPr sz="850">
-                <a:solidFill>
-                  <a:srgbClr val="0F172A"/>
-                </a:solidFill>
-                <a:latin typeface="Arial"/>
-              </a:rPr>
-              <a:t>// Dynamic Method Dispatch loop in QuizRunner:
-for (Question q : currentQuiz.getQuestions()) {
-    q.displayQuestion(); // Dynamically binds to MCQ / TF / Numeric via vtable
-    boolean isCorrect = q.checkAnswer(userInput); // Dynamic runtime dispatch
-}</a:t>
-            </a:r>
-          </a:p>
-          <a:p>
-            <a:pPr>
-              <a:spcAft>
-                <a:spcPts val="300"/>
-              </a:spcAft>
-            </a:pPr>
-            <a:r>
-              <a:rPr b="1" sz="850">
-                <a:solidFill>
-                  <a:srgbClr val="0F172A"/>
-                </a:solidFill>
-                <a:latin typeface="Arial"/>
-              </a:rPr>
-              <a:t>Viva Defense (Rubric Answer) — </a:t>
-            </a:r>
-            <a:r>
-              <a:rPr sz="850">
-                <a:solidFill>
-                  <a:srgbClr val="0F172A"/>
-                </a:solidFill>
-                <a:latin typeface="Arial"/>
-              </a:rPr>
-              <a:t>Q: Where is runtime polymorphism used? Explain the dispatch mechanism.
-A: In QuizRunner when calling q.displayQuestion(). Although q is typed as Question, the JVM inspects the object header at runtime and invokes MultipleChoiceQuestion.displayQuestion() or NumericQuestion.displayQuestion().</a:t>
-            </a:r>
-          </a:p>
-        </p:txBody>
-      </p:sp>
-      <p:sp>
-        <p:nvSpPr>
-          <p:cNvPr id="9" name="Rounded Rectangle 8"/>
-          <p:cNvSpPr/>
-          <p:nvPr/>
-        </p:nvSpPr>
-        <p:spPr>
-          <a:xfrm>
-            <a:off x="6199632" y="2148840"/>
-            <a:ext cx="5257800" cy="4389120"/>
-          </a:xfrm>
-          <a:prstGeom prst="roundRect">
-            <a:avLst/>
-          </a:prstGeom>
-          <a:solidFill>
-            <a:srgbClr val="FFFFFF"/>
-          </a:solidFill>
-          <a:ln w="19050">
-            <a:solidFill>
-              <a:srgbClr val="EA580C"/>
-            </a:solidFill>
-          </a:ln>
-        </p:spPr>
-        <p:style>
-          <a:lnRef idx="1">
-            <a:schemeClr val="accent1"/>
-          </a:lnRef>
-          <a:fillRef idx="3">
-            <a:schemeClr val="accent1"/>
-          </a:fillRef>
-          <a:effectRef idx="2">
-            <a:schemeClr val="accent1"/>
-          </a:effectRef>
-          <a:fontRef idx="minor">
-            <a:schemeClr val="lt1"/>
-          </a:fontRef>
-        </p:style>
-        <p:txBody>
-          <a:bodyPr rtlCol="0" anchor="ctr" wrap="square" lIns="182880" rIns="182880" tIns="164592" bIns="164592"/>
-          <a:lstStyle/>
-          <a:p>
-            <a:pPr algn="ctr">
-              <a:spcAft>
-                <a:spcPts val="200"/>
-              </a:spcAft>
-              <a:defRPr sz="850" b="1">
-                <a:solidFill>
-                  <a:srgbClr val="2563EB"/>
-                </a:solidFill>
-                <a:latin typeface="Arial"/>
-              </a:defRPr>
-            </a:pPr>
-            <a:r>
-              <a:t>UNIT IV: ERROR &amp; EXCEPTION HANDLING</a:t>
-            </a:r>
-          </a:p>
-          <a:p>
-            <a:pPr>
-              <a:spcAft>
-                <a:spcPts val="400"/>
-              </a:spcAft>
-              <a:defRPr sz="1200" b="1">
-                <a:solidFill>
-                  <a:srgbClr val="1B365D"/>
-                </a:solidFill>
-                <a:latin typeface="Arial"/>
-              </a:defRPr>
-            </a:pPr>
-            <a:r>
-              <a:t>Unit IV: Types of Exceptions &amp; Exception Propagation</a:t>
-            </a:r>
-          </a:p>
-          <a:p>
-            <a:pPr>
-              <a:spcAft>
-                <a:spcPts val="300"/>
-              </a:spcAft>
-            </a:pPr>
-            <a:r>
-              <a:rPr b="1" sz="850">
-                <a:solidFill>
-                  <a:srgbClr val="0F172A"/>
-                </a:solidFill>
-                <a:latin typeface="Arial"/>
-              </a:rPr>
-              <a:t>Syllabus Topic &amp; Definition — </a:t>
-            </a:r>
-            <a:r>
-              <a:rPr sz="850">
-                <a:solidFill>
-                  <a:srgbClr val="0F172A"/>
-                </a:solidFill>
-                <a:latin typeface="Arial"/>
-              </a:rPr>
-              <a:t>Types of Exceptions and Propagation (SPPU Unit IV). Java divides throwables into unchecked RuntimeException (subclasses of RuntimeException that the compiler ignores) and checked Exception (enforced by compiler requiring explicit 'throws' or 'try-catch').</a:t>
-            </a:r>
-          </a:p>
-          <a:p>
-            <a:pPr>
-              <a:spcAft>
-                <a:spcPts val="300"/>
-              </a:spcAft>
-            </a:pPr>
-            <a:r>
-              <a:rPr b="1" sz="850">
-                <a:solidFill>
-                  <a:srgbClr val="0F172A"/>
-                </a:solidFill>
-                <a:latin typeface="Arial"/>
-              </a:rPr>
-              <a:t>Operational Failure &amp; Mitigation — </a:t>
-            </a:r>
-            <a:r>
-              <a:rPr sz="850">
-                <a:solidFill>
-                  <a:srgbClr val="0F172A"/>
-                </a:solidFill>
-                <a:latin typeface="Arial"/>
-              </a:rPr>
-              <a:t>If students enter non-numeric input for numeric questions or invalid letters for MCQs, unhandled exceptions would abruptly terminate the examination process, losing all student answers.</a:t>
-            </a:r>
-          </a:p>
-          <a:p>
-            <a:pPr>
-              <a:spcAft>
-                <a:spcPts val="300"/>
-              </a:spcAft>
-            </a:pPr>
-            <a:r>
-              <a:rPr b="1" sz="850">
-                <a:solidFill>
-                  <a:srgbClr val="0F172A"/>
-                </a:solidFill>
-                <a:latin typeface="Arial"/>
-              </a:rPr>
-              <a:t>Project Implementation — </a:t>
-            </a:r>
-            <a:r>
-              <a:rPr sz="850">
-                <a:solidFill>
-                  <a:srgbClr val="0F172A"/>
-                </a:solidFill>
-                <a:latin typeface="Arial"/>
-              </a:rPr>
-              <a:t>Protected question evaluation by declaring checked InvalidOptionException on checkAnswer(). Traps NumberFormatException internally for numeric types and bubbles InvalidOptionException up to the caller to prompt the student for an immediate retry.</a:t>
-            </a:r>
-          </a:p>
-          <a:p>
-            <a:pPr>
-              <a:spcAft>
-                <a:spcPts val="300"/>
-              </a:spcAft>
-            </a:pPr>
-            <a:r>
-              <a:rPr b="1" sz="850">
-                <a:solidFill>
-                  <a:srgbClr val="0F172A"/>
-                </a:solidFill>
-                <a:latin typeface="Arial"/>
-              </a:rPr>
-              <a:t>Code Snippet — </a:t>
-            </a:r>
-            <a:r>
-              <a:rPr sz="850">
-                <a:solidFill>
-                  <a:srgbClr val="0F172A"/>
-                </a:solidFill>
-                <a:latin typeface="Arial"/>
-              </a:rPr>
-              <a:t>@Override
-public boolean checkAnswer(String answer) throws InvalidOptionException {
-    if (answer == null || answer.trim().isEmpty())
-        throw new InvalidOptionException("Option cannot be empty.");
-    // Validate range and return comparison...
-}</a:t>
-            </a:r>
-          </a:p>
-          <a:p>
-            <a:pPr>
-              <a:spcAft>
-                <a:spcPts val="300"/>
-              </a:spcAft>
-            </a:pPr>
-            <a:r>
-              <a:rPr b="1" sz="850">
-                <a:solidFill>
-                  <a:srgbClr val="0F172A"/>
-                </a:solidFill>
-                <a:latin typeface="Arial"/>
-              </a:rPr>
-              <a:t>Viva Defense (Rubric Answer) — </a:t>
-            </a:r>
-            <a:r>
-              <a:rPr sz="850">
-                <a:solidFill>
-                  <a:srgbClr val="0F172A"/>
-                </a:solidFill>
-                <a:latin typeface="Arial"/>
-              </a:rPr>
-              <a:t>Q: Why is InvalidOptionException a checked exception rather than unchecked?
-A: To force the calling UI/runner at compile time to implement a try-catch block, ensuring that an invalid input can never slip through and terminate the student's exam session.</a:t>
-            </a:r>
-          </a:p>
-        </p:txBody>
-      </p:sp>
-    </p:spTree>
-  </p:cSld>
-  <p:clrMapOvr>
-    <a:masterClrMapping/>
-  </p:clrMapOvr>
-</p:sld>
-</file>
-
-<file path=ppt/slides/slide14.xml><?xml version="1.0" encoding="utf-8"?>
-<p:sld xmlns:a="http://schemas.openxmlformats.org/drawingml/2006/main" xmlns:p="http://schemas.openxmlformats.org/presentationml/2006/main" xmlns:r="http://schemas.openxmlformats.org/officeDocument/2006/relationships">
-  <p:cSld>
-    <p:spTree>
-      <p:nvGrpSpPr>
-        <p:cNvPr id="1" name=""/>
-        <p:cNvGrpSpPr/>
-        <p:nvPr/>
-      </p:nvGrpSpPr>
-      <p:grpSpPr/>
-      <p:sp>
-        <p:nvSpPr>
-          <p:cNvPr id="2" name="Rectangle 1"/>
-          <p:cNvSpPr/>
-          <p:nvPr/>
-        </p:nvSpPr>
-        <p:spPr>
-          <a:xfrm>
-            <a:off x="0" y="0"/>
-            <a:ext cx="12191695" cy="6858000"/>
-          </a:xfrm>
-          <a:prstGeom prst="rect">
-            <a:avLst/>
-          </a:prstGeom>
-          <a:solidFill>
-            <a:srgbClr val="FBF9F4"/>
-          </a:solidFill>
-          <a:ln>
-            <a:noFill/>
-          </a:ln>
-        </p:spPr>
-        <p:style>
-          <a:lnRef idx="1">
-            <a:schemeClr val="accent1"/>
-          </a:lnRef>
-          <a:fillRef idx="3">
-            <a:schemeClr val="accent1"/>
-          </a:fillRef>
-          <a:effectRef idx="2">
-            <a:schemeClr val="accent1"/>
-          </a:effectRef>
-          <a:fontRef idx="minor">
-            <a:schemeClr val="lt1"/>
-          </a:fontRef>
-        </p:style>
-        <p:txBody>
-          <a:bodyPr rtlCol="0" anchor="ctr"/>
-          <a:lstStyle/>
-          <a:p>
-            <a:pPr algn="ctr"/>
-          </a:p>
-        </p:txBody>
-      </p:sp>
-      <p:sp>
-        <p:nvSpPr>
-          <p:cNvPr id="3" name="Rectangle 2"/>
-          <p:cNvSpPr/>
-          <p:nvPr/>
-        </p:nvSpPr>
-        <p:spPr>
-          <a:xfrm>
-            <a:off x="731520" y="365760"/>
-            <a:ext cx="10698480" cy="36576"/>
-          </a:xfrm>
-          <a:prstGeom prst="rect">
-            <a:avLst/>
-          </a:prstGeom>
-          <a:solidFill>
-            <a:srgbClr val="1B365D"/>
-          </a:solidFill>
-          <a:ln>
-            <a:noFill/>
-          </a:ln>
-        </p:spPr>
-        <p:style>
-          <a:lnRef idx="1">
-            <a:schemeClr val="accent1"/>
-          </a:lnRef>
-          <a:fillRef idx="3">
-            <a:schemeClr val="accent1"/>
-          </a:fillRef>
-          <a:effectRef idx="2">
-            <a:schemeClr val="accent1"/>
-          </a:effectRef>
-          <a:fontRef idx="minor">
-            <a:schemeClr val="lt1"/>
-          </a:fontRef>
-        </p:style>
-        <p:txBody>
-          <a:bodyPr rtlCol="0" anchor="ctr"/>
-          <a:lstStyle/>
-          <a:p>
-            <a:pPr algn="ctr"/>
-          </a:p>
-        </p:txBody>
-      </p:sp>
-      <p:sp>
-        <p:nvSpPr>
-          <p:cNvPr id="4" name="TextBox 3"/>
-          <p:cNvSpPr txBox="1"/>
-          <p:nvPr/>
-        </p:nvSpPr>
-        <p:spPr>
-          <a:xfrm>
-            <a:off x="731520" y="411480"/>
-            <a:ext cx="9326880" cy="822960"/>
-          </a:xfrm>
-          <a:prstGeom prst="rect">
-            <a:avLst/>
-          </a:prstGeom>
-          <a:noFill/>
-        </p:spPr>
-        <p:txBody>
-          <a:bodyPr wrap="square" lIns="0" tIns="0" rIns="0" bIns="0">
-            <a:spAutoFit/>
-          </a:bodyPr>
-          <a:lstStyle/>
-          <a:p>
-            <a:pPr>
-              <a:defRPr sz="2200" b="1">
-                <a:solidFill>
-                  <a:srgbClr val="1B365D"/>
-                </a:solidFill>
-                <a:latin typeface="Arial"/>
-              </a:defRPr>
-            </a:pPr>
-            <a:r>
-              <a:t>TEAMMATE DEFENSE: PRIYAM RAJ (ROLL: 8134)</a:t>
-            </a:r>
-          </a:p>
-          <a:p>
-            <a:pPr>
-              <a:defRPr sz="1100" b="1">
-                <a:solidFill>
-                  <a:srgbClr val="EA580C"/>
-                </a:solidFill>
-                <a:latin typeface="Arial"/>
-              </a:defRPr>
-            </a:pPr>
-            <a:r>
-              <a:t>SE IT B • ASSIGNED ROLE: SERVICE ARCHITECT &amp; STRATEGY PATTERN ENGINEER • UNIT III &amp; IV TOPIC DEEP DIVE</a:t>
-            </a:r>
-          </a:p>
-        </p:txBody>
-      </p:sp>
-      <p:pic>
-        <p:nvPicPr>
-          <p:cNvPr id="5" name="Picture 4" descr="ait_official_badge.png"/>
-          <p:cNvPicPr>
-            <a:picLocks noChangeAspect="1"/>
-          </p:cNvPicPr>
-          <p:nvPr/>
-        </p:nvPicPr>
-        <p:blipFill>
-          <a:blip r:embed="rId2"/>
-          <a:stretch>
-            <a:fillRect/>
-          </a:stretch>
-        </p:blipFill>
-        <p:spPr>
-          <a:xfrm>
-            <a:off x="10789920" y="320040"/>
-            <a:ext cx="868680" cy="868680"/>
-          </a:xfrm>
-          <a:prstGeom prst="rect">
-            <a:avLst/>
-          </a:prstGeom>
-        </p:spPr>
-      </p:pic>
-      <p:sp>
-        <p:nvSpPr>
-          <p:cNvPr id="6" name="TextBox 5"/>
-          <p:cNvSpPr txBox="1"/>
-          <p:nvPr/>
-        </p:nvSpPr>
-        <p:spPr>
-          <a:xfrm>
-            <a:off x="11155680" y="6400800"/>
-            <a:ext cx="731520" cy="365760"/>
-          </a:xfrm>
-          <a:prstGeom prst="rect">
-            <a:avLst/>
-          </a:prstGeom>
-          <a:noFill/>
-        </p:spPr>
-        <p:txBody>
-          <a:bodyPr wrap="none">
-            <a:spAutoFit/>
-          </a:bodyPr>
-          <a:lstStyle/>
-          <a:p>
-            <a:pPr>
-              <a:defRPr sz="1200">
-                <a:solidFill>
-                  <a:srgbClr val="64748B"/>
-                </a:solidFill>
-                <a:latin typeface="Arial"/>
-              </a:defRPr>
-            </a:pPr>
-            <a:r>
-              <a:t>14</a:t>
-            </a:r>
-          </a:p>
-        </p:txBody>
-      </p:sp>
-      <p:sp>
-        <p:nvSpPr>
-          <p:cNvPr id="7" name="Rounded Rectangle 6"/>
-          <p:cNvSpPr/>
-          <p:nvPr/>
-        </p:nvSpPr>
-        <p:spPr>
-          <a:xfrm>
-            <a:off x="731520" y="1371600"/>
-            <a:ext cx="10728655" cy="685800"/>
-          </a:xfrm>
-          <a:prstGeom prst="roundRect">
-            <a:avLst/>
-          </a:prstGeom>
-          <a:solidFill>
-            <a:srgbClr val="1E293B"/>
-          </a:solidFill>
-          <a:ln w="19050">
-            <a:solidFill>
-              <a:srgbClr val="7E22CE"/>
-            </a:solidFill>
-          </a:ln>
-        </p:spPr>
-        <p:style>
-          <a:lnRef idx="1">
-            <a:schemeClr val="accent1"/>
-          </a:lnRef>
-          <a:fillRef idx="3">
-            <a:schemeClr val="accent1"/>
-          </a:fillRef>
-          <a:effectRef idx="2">
-            <a:schemeClr val="accent1"/>
-          </a:effectRef>
-          <a:fontRef idx="minor">
-            <a:schemeClr val="lt1"/>
-          </a:fontRef>
-        </p:style>
-        <p:txBody>
-          <a:bodyPr rtlCol="0" anchor="ctr" wrap="square" lIns="228600" rIns="228600" tIns="109728"/>
-          <a:lstStyle/>
-          <a:p>
-            <a:pPr algn="ctr"/>
-            <a:r>
-              <a:rPr b="1" sz="1300">
-                <a:solidFill>
-                  <a:srgbClr val="FFFFFF"/>
-                </a:solidFill>
-              </a:rPr>
-              <a:t>STUDENT: Priyam Raj  </a:t>
-            </a:r>
-            <a:r>
-              <a:rPr b="1" sz="1100">
-                <a:solidFill>
-                  <a:srgbClr val="EA580C"/>
-                </a:solidFill>
-              </a:rPr>
-              <a:t>•  ROLL NO: 8134  •  CLASS: SE IT B  •  </a:t>
-            </a:r>
-            <a:r>
-              <a:rPr b="1" sz="1100">
-                <a:solidFill>
-                  <a:srgbClr val="7E22CE"/>
-                </a:solidFill>
-              </a:rPr>
-              <a:t>ROLE: Service Architect &amp; Strategy Pattern Engineer  •  SPPU BIT25434A0X (CO3, CO4)</a:t>
-            </a:r>
-          </a:p>
-        </p:txBody>
-      </p:sp>
-      <p:sp>
-        <p:nvSpPr>
-          <p:cNvPr id="8" name="Rounded Rectangle 7"/>
-          <p:cNvSpPr/>
-          <p:nvPr/>
-        </p:nvSpPr>
-        <p:spPr>
-          <a:xfrm>
-            <a:off x="731520" y="2148840"/>
-            <a:ext cx="5257800" cy="4389120"/>
-          </a:xfrm>
-          <a:prstGeom prst="roundRect">
-            <a:avLst/>
-          </a:prstGeom>
-          <a:solidFill>
-            <a:srgbClr val="FFFFFF"/>
-          </a:solidFill>
-          <a:ln w="19050">
-            <a:solidFill>
-              <a:srgbClr val="2563EB"/>
-            </a:solidFill>
-          </a:ln>
-        </p:spPr>
-        <p:style>
-          <a:lnRef idx="1">
-            <a:schemeClr val="accent1"/>
-          </a:lnRef>
-          <a:fillRef idx="3">
-            <a:schemeClr val="accent1"/>
-          </a:fillRef>
-          <a:effectRef idx="2">
-            <a:schemeClr val="accent1"/>
-          </a:effectRef>
-          <a:fontRef idx="minor">
-            <a:schemeClr val="lt1"/>
-          </a:fontRef>
-        </p:style>
-        <p:txBody>
-          <a:bodyPr rtlCol="0" anchor="ctr" wrap="square" lIns="182880" rIns="182880" tIns="164592" bIns="164592"/>
-          <a:lstStyle/>
-          <a:p>
-            <a:pPr algn="ctr">
-              <a:spcAft>
-                <a:spcPts val="200"/>
-              </a:spcAft>
-              <a:defRPr sz="850" b="1">
-                <a:solidFill>
-                  <a:srgbClr val="2563EB"/>
-                </a:solidFill>
-                <a:latin typeface="Arial"/>
-              </a:defRPr>
-            </a:pPr>
-            <a:r>
-              <a:t>UNIT III: POLYMORPHISM &amp; INTERFACES</a:t>
-            </a:r>
-          </a:p>
-          <a:p>
-            <a:pPr>
-              <a:spcAft>
-                <a:spcPts val="400"/>
-              </a:spcAft>
-              <a:defRPr sz="1200" b="1">
-                <a:solidFill>
-                  <a:srgbClr val="1B365D"/>
-                </a:solidFill>
-                <a:latin typeface="Arial"/>
-              </a:defRPr>
-            </a:pPr>
-            <a:r>
-              <a:t>Unit III: Interfaces &amp; Behavioral Strategy Design Pattern</a:t>
-            </a:r>
-          </a:p>
-          <a:p>
-            <a:pPr>
-              <a:spcAft>
-                <a:spcPts val="300"/>
-              </a:spcAft>
-            </a:pPr>
-            <a:r>
-              <a:rPr b="1" sz="850">
-                <a:solidFill>
-                  <a:srgbClr val="0F172A"/>
-                </a:solidFill>
-                <a:latin typeface="Arial"/>
-              </a:rPr>
-              <a:t>Syllabus Topic &amp; Definition — </a:t>
-            </a:r>
-            <a:r>
-              <a:rPr sz="850">
-                <a:solidFill>
-                  <a:srgbClr val="0F172A"/>
-                </a:solidFill>
-                <a:latin typeface="Arial"/>
-              </a:rPr>
-              <a:t>Interfaces (SPPU Unit III). An interface is a pure contract declaring abstract methods without instance fields. Classes realize interfaces via 'implements'. Facilitates loose coupling and the Strategy Design Pattern where algorithms are encapsulated and swapped at runtime.</a:t>
-            </a:r>
-          </a:p>
-          <a:p>
-            <a:pPr>
-              <a:spcAft>
-                <a:spcPts val="300"/>
-              </a:spcAft>
-            </a:pPr>
-            <a:r>
-              <a:rPr b="1" sz="850">
-                <a:solidFill>
-                  <a:srgbClr val="0F172A"/>
-                </a:solidFill>
-                <a:latin typeface="Arial"/>
-              </a:rPr>
-              <a:t>Why Used in Architecture — </a:t>
-            </a:r>
-            <a:r>
-              <a:rPr sz="850">
-                <a:solidFill>
-                  <a:srgbClr val="0F172A"/>
-                </a:solidFill>
-                <a:latin typeface="Arial"/>
-              </a:rPr>
-              <a:t>Colleges conduct standard tests (no penalty) and competitive mock tests (25% negative marking). Hardcoding math inside QuizRunner violates Open/Closed Principle. Abstracting scoring behind QuizEvaluator enables pluggable scoring rules.</a:t>
-            </a:r>
-          </a:p>
-          <a:p>
-            <a:pPr>
-              <a:spcAft>
-                <a:spcPts val="300"/>
-              </a:spcAft>
-            </a:pPr>
-            <a:r>
-              <a:rPr b="1" sz="850">
-                <a:solidFill>
-                  <a:srgbClr val="0F172A"/>
-                </a:solidFill>
-                <a:latin typeface="Arial"/>
-              </a:rPr>
-              <a:t>Project Implementation — </a:t>
-            </a:r>
-            <a:r>
-              <a:rPr sz="850">
-                <a:solidFill>
-                  <a:srgbClr val="0F172A"/>
-                </a:solidFill>
-                <a:latin typeface="Arial"/>
-              </a:rPr>
-              <a:t>Designed QuizOperations interface for CRUD operations. Designed QuizEvaluator strategy interface implemented by: (1) StandardGradingPolicy (linear 100% score, 0% penalty) and (2) NegativeMarkingGradingPolicy (competitive 25% negative penalty deduction for wrong answers).</a:t>
-            </a:r>
-          </a:p>
-          <a:p>
-            <a:pPr>
-              <a:spcAft>
-                <a:spcPts val="300"/>
-              </a:spcAft>
-            </a:pPr>
-            <a:r>
-              <a:rPr b="1" sz="850">
-                <a:solidFill>
-                  <a:srgbClr val="0F172A"/>
-                </a:solidFill>
-                <a:latin typeface="Arial"/>
-              </a:rPr>
-              <a:t>Code Snippet — </a:t>
-            </a:r>
-            <a:r>
-              <a:rPr sz="850">
-                <a:solidFill>
-                  <a:srgbClr val="0F172A"/>
-                </a:solidFill>
-                <a:latin typeface="Arial"/>
-              </a:rPr>
-              <a:t>public interface QuizEvaluator { double evaluateScore(QuizAttempt attempt); }
-// Pluggable strategy execution:
-QuizEvaluator evaluator = isCompetitive ? 
-    new NegativeMarkingGradingPolicy() : new StandardGradingPolicy();
-double finalScore = evaluator.evaluateScore(attempt);</a:t>
-            </a:r>
-          </a:p>
-          <a:p>
-            <a:pPr>
-              <a:spcAft>
-                <a:spcPts val="300"/>
-              </a:spcAft>
-            </a:pPr>
-            <a:r>
-              <a:rPr b="1" sz="850">
-                <a:solidFill>
-                  <a:srgbClr val="0F172A"/>
-                </a:solidFill>
-                <a:latin typeface="Arial"/>
-              </a:rPr>
-              <a:t>Viva Defense (Rubric Answer) — </a:t>
-            </a:r>
-            <a:r>
-              <a:rPr sz="850">
-                <a:solidFill>
-                  <a:srgbClr val="0F172A"/>
-                </a:solidFill>
-                <a:latin typeface="Arial"/>
-              </a:rPr>
-              <a:t>Q: Why create the QuizEvaluator interface? How does it satisfy Open/Closed Principle?
-A: It decouples grading algorithms from test conduction. To add a new grading policy (e.g. 50% penalty), we create a new class implementing QuizEvaluator without changing a single line in QuizRunner.</a:t>
-            </a:r>
-          </a:p>
-        </p:txBody>
-      </p:sp>
-      <p:sp>
-        <p:nvSpPr>
-          <p:cNvPr id="9" name="Rounded Rectangle 8"/>
-          <p:cNvSpPr/>
-          <p:nvPr/>
-        </p:nvSpPr>
-        <p:spPr>
-          <a:xfrm>
-            <a:off x="6199632" y="2148840"/>
-            <a:ext cx="5257800" cy="4389120"/>
-          </a:xfrm>
-          <a:prstGeom prst="roundRect">
-            <a:avLst/>
-          </a:prstGeom>
-          <a:solidFill>
-            <a:srgbClr val="FFFFFF"/>
-          </a:solidFill>
-          <a:ln w="19050">
-            <a:solidFill>
-              <a:srgbClr val="EA580C"/>
-            </a:solidFill>
-          </a:ln>
-        </p:spPr>
-        <p:style>
-          <a:lnRef idx="1">
-            <a:schemeClr val="accent1"/>
-          </a:lnRef>
-          <a:fillRef idx="3">
-            <a:schemeClr val="accent1"/>
-          </a:fillRef>
-          <a:effectRef idx="2">
-            <a:schemeClr val="accent1"/>
-          </a:effectRef>
-          <a:fontRef idx="minor">
-            <a:schemeClr val="lt1"/>
-          </a:fontRef>
-        </p:style>
-        <p:txBody>
-          <a:bodyPr rtlCol="0" anchor="ctr" wrap="square" lIns="182880" rIns="182880" tIns="164592" bIns="164592"/>
-          <a:lstStyle/>
-          <a:p>
-            <a:pPr algn="ctr">
-              <a:spcAft>
-                <a:spcPts val="200"/>
-              </a:spcAft>
-              <a:defRPr sz="850" b="1">
-                <a:solidFill>
-                  <a:srgbClr val="2563EB"/>
-                </a:solidFill>
-                <a:latin typeface="Arial"/>
-              </a:defRPr>
-            </a:pPr>
-            <a:r>
-              <a:t>UNIT IV: ERROR &amp; EXCEPTION HANDLING</a:t>
-            </a:r>
-          </a:p>
-          <a:p>
-            <a:pPr>
-              <a:spcAft>
-                <a:spcPts val="400"/>
-              </a:spcAft>
-              <a:defRPr sz="1200" b="1">
-                <a:solidFill>
-                  <a:srgbClr val="1B365D"/>
-                </a:solidFill>
-                <a:latin typeface="Arial"/>
-              </a:defRPr>
-            </a:pPr>
-            <a:r>
-              <a:t>Unit IV: Exception Handling Mechanism (try, catch, finally, throws)</a:t>
-            </a:r>
-          </a:p>
-          <a:p>
-            <a:pPr>
-              <a:spcAft>
-                <a:spcPts val="300"/>
-              </a:spcAft>
-            </a:pPr>
-            <a:r>
-              <a:rPr b="1" sz="850">
-                <a:solidFill>
-                  <a:srgbClr val="0F172A"/>
-                </a:solidFill>
-                <a:latin typeface="Arial"/>
-              </a:rPr>
-              <a:t>Syllabus Topic &amp; Definition — </a:t>
-            </a:r>
-            <a:r>
-              <a:rPr sz="850">
-                <a:solidFill>
-                  <a:srgbClr val="0F172A"/>
-                </a:solidFill>
-                <a:latin typeface="Arial"/>
-              </a:rPr>
-              <a:t>Exception Handling Mechanism (SPPU Unit IV). Uses 5 keywords: 'try' isolates risky code; 'catch' handles specific exceptions; 'finally' guarantees unconditional execution for cleanup; 'throw' raises exceptions; 'throws' declares exceptions in method signatures.</a:t>
-            </a:r>
-          </a:p>
-          <a:p>
-            <a:pPr>
-              <a:spcAft>
-                <a:spcPts val="300"/>
-              </a:spcAft>
-            </a:pPr>
-            <a:r>
-              <a:rPr b="1" sz="850">
-                <a:solidFill>
-                  <a:srgbClr val="0F172A"/>
-                </a:solidFill>
-                <a:latin typeface="Arial"/>
-              </a:rPr>
-              <a:t>Operational Failure &amp; Mitigation — </a:t>
-            </a:r>
-            <a:r>
-              <a:rPr sz="850">
-                <a:solidFill>
-                  <a:srgbClr val="0F172A"/>
-                </a:solidFill>
-                <a:latin typeface="Arial"/>
-              </a:rPr>
-              <a:t>System resource leaks (open scanners, uncommitted audit logs) occur if exceptions disrupt execution. Unregistered quiz lookups crash the application if missing IDs are not caught.</a:t>
-            </a:r>
-          </a:p>
-          <a:p>
-            <a:pPr>
-              <a:spcAft>
-                <a:spcPts val="300"/>
-              </a:spcAft>
-            </a:pPr>
-            <a:r>
-              <a:rPr b="1" sz="850">
-                <a:solidFill>
-                  <a:srgbClr val="0F172A"/>
-                </a:solidFill>
-                <a:latin typeface="Arial"/>
-              </a:rPr>
-              <a:t>Project Implementation — </a:t>
-            </a:r>
-            <a:r>
-              <a:rPr sz="850">
-                <a:solidFill>
-                  <a:srgbClr val="0F172A"/>
-                </a:solidFill>
-                <a:latin typeface="Arial"/>
-              </a:rPr>
-              <a:t>Declared checked exceptions in interface contracts (throws QuizNotFoundException, DuplicateQuizException). Wrapped quiz execution inside try-catch-finally, where 'finally' guarantees session audit logging and clean resource termination.</a:t>
-            </a:r>
-          </a:p>
-          <a:p>
-            <a:pPr>
-              <a:spcAft>
-                <a:spcPts val="300"/>
-              </a:spcAft>
-            </a:pPr>
-            <a:r>
-              <a:rPr b="1" sz="850">
-                <a:solidFill>
-                  <a:srgbClr val="0F172A"/>
-                </a:solidFill>
-                <a:latin typeface="Arial"/>
-              </a:rPr>
-              <a:t>Code Snippet — </a:t>
-            </a:r>
-            <a:r>
-              <a:rPr sz="850">
-                <a:solidFill>
-                  <a:srgbClr val="0F172A"/>
-                </a:solidFill>
-                <a:latin typeface="Arial"/>
-              </a:rPr>
-              <a:t>try {
-    Quiz quiz = quizManager.getQuiz(quizId);
-    conductQuiz(quiz, evaluator);
-} catch (QuizNotFoundException | EmptyQuizException e) {
-    System.err.println("Quiz Error: " + e.getMessage());
-} finally {
-    auditLogger.recordSessionClosure(); // Always executes
-}</a:t>
-            </a:r>
-          </a:p>
-          <a:p>
-            <a:pPr>
-              <a:spcAft>
-                <a:spcPts val="300"/>
-              </a:spcAft>
-            </a:pPr>
-            <a:r>
-              <a:rPr b="1" sz="850">
-                <a:solidFill>
-                  <a:srgbClr val="0F172A"/>
-                </a:solidFill>
-                <a:latin typeface="Arial"/>
-              </a:rPr>
-              <a:t>Viva Defense (Rubric Answer) — </a:t>
-            </a:r>
-            <a:r>
-              <a:rPr sz="850">
-                <a:solidFill>
-                  <a:srgbClr val="0F172A"/>
-                </a:solidFill>
-                <a:latin typeface="Arial"/>
-              </a:rPr>
-              <a:t>Q: What is the purpose of try, catch, and finally? Does finally always run?
-A: 'try' monitors critical blocks; 'catch' provides recovery; 'finally' guarantees cleanup (closing files, streams). Yes, finally executes unconditionally even if an exception or return occurs in try/catch.</a:t>
-            </a:r>
-          </a:p>
-        </p:txBody>
-      </p:sp>
-    </p:spTree>
-  </p:cSld>
-  <p:clrMapOvr>
-    <a:masterClrMapping/>
-  </p:clrMapOvr>
-</p:sld>
-</file>
-
-<file path=ppt/slides/slide15.xml><?xml version="1.0" encoding="utf-8"?>
-<p:sld xmlns:a="http://schemas.openxmlformats.org/drawingml/2006/main" xmlns:p="http://schemas.openxmlformats.org/presentationml/2006/main" xmlns:r="http://schemas.openxmlformats.org/officeDocument/2006/relationships">
-  <p:cSld>
-    <p:spTree>
-      <p:nvGrpSpPr>
-        <p:cNvPr id="1" name=""/>
-        <p:cNvGrpSpPr/>
-        <p:nvPr/>
-      </p:nvGrpSpPr>
-      <p:grpSpPr/>
-      <p:sp>
-        <p:nvSpPr>
-          <p:cNvPr id="2" name="Rectangle 1"/>
-          <p:cNvSpPr/>
-          <p:nvPr/>
-        </p:nvSpPr>
-        <p:spPr>
-          <a:xfrm>
-            <a:off x="0" y="0"/>
-            <a:ext cx="12191695" cy="6858000"/>
-          </a:xfrm>
-          <a:prstGeom prst="rect">
-            <a:avLst/>
-          </a:prstGeom>
-          <a:solidFill>
-            <a:srgbClr val="FBF9F4"/>
-          </a:solidFill>
-          <a:ln>
-            <a:noFill/>
-          </a:ln>
-        </p:spPr>
-        <p:style>
-          <a:lnRef idx="1">
-            <a:schemeClr val="accent1"/>
-          </a:lnRef>
-          <a:fillRef idx="3">
-            <a:schemeClr val="accent1"/>
-          </a:fillRef>
-          <a:effectRef idx="2">
-            <a:schemeClr val="accent1"/>
-          </a:effectRef>
-          <a:fontRef idx="minor">
-            <a:schemeClr val="lt1"/>
-          </a:fontRef>
-        </p:style>
-        <p:txBody>
-          <a:bodyPr rtlCol="0" anchor="ctr"/>
-          <a:lstStyle/>
-          <a:p>
-            <a:pPr algn="ctr"/>
-          </a:p>
-        </p:txBody>
-      </p:sp>
-      <p:sp>
-        <p:nvSpPr>
-          <p:cNvPr id="3" name="Rectangle 2"/>
-          <p:cNvSpPr/>
-          <p:nvPr/>
-        </p:nvSpPr>
-        <p:spPr>
-          <a:xfrm>
-            <a:off x="731520" y="365760"/>
-            <a:ext cx="10698480" cy="36576"/>
-          </a:xfrm>
-          <a:prstGeom prst="rect">
-            <a:avLst/>
-          </a:prstGeom>
-          <a:solidFill>
-            <a:srgbClr val="1B365D"/>
-          </a:solidFill>
-          <a:ln>
-            <a:noFill/>
-          </a:ln>
-        </p:spPr>
-        <p:style>
-          <a:lnRef idx="1">
-            <a:schemeClr val="accent1"/>
-          </a:lnRef>
-          <a:fillRef idx="3">
-            <a:schemeClr val="accent1"/>
-          </a:fillRef>
-          <a:effectRef idx="2">
-            <a:schemeClr val="accent1"/>
-          </a:effectRef>
-          <a:fontRef idx="minor">
-            <a:schemeClr val="lt1"/>
-          </a:fontRef>
-        </p:style>
-        <p:txBody>
-          <a:bodyPr rtlCol="0" anchor="ctr"/>
-          <a:lstStyle/>
-          <a:p>
-            <a:pPr algn="ctr"/>
-          </a:p>
-        </p:txBody>
-      </p:sp>
-      <p:sp>
-        <p:nvSpPr>
-          <p:cNvPr id="4" name="TextBox 3"/>
-          <p:cNvSpPr txBox="1"/>
-          <p:nvPr/>
-        </p:nvSpPr>
-        <p:spPr>
-          <a:xfrm>
-            <a:off x="731520" y="411480"/>
-            <a:ext cx="9326880" cy="822960"/>
-          </a:xfrm>
-          <a:prstGeom prst="rect">
-            <a:avLst/>
-          </a:prstGeom>
-          <a:noFill/>
-        </p:spPr>
-        <p:txBody>
-          <a:bodyPr wrap="square" lIns="0" tIns="0" rIns="0" bIns="0">
-            <a:spAutoFit/>
-          </a:bodyPr>
-          <a:lstStyle/>
-          <a:p>
-            <a:pPr>
-              <a:defRPr sz="2200" b="1">
-                <a:solidFill>
-                  <a:srgbClr val="1B365D"/>
-                </a:solidFill>
-                <a:latin typeface="Arial"/>
-              </a:defRPr>
-            </a:pPr>
-            <a:r>
-              <a:t>TEAMMATE DEFENSE: UTKARSH CHAUHAN (ROLL: 8154)</a:t>
-            </a:r>
-          </a:p>
-          <a:p>
-            <a:pPr>
-              <a:defRPr sz="1100" b="1">
-                <a:solidFill>
-                  <a:srgbClr val="EA580C"/>
-                </a:solidFill>
-                <a:latin typeface="Arial"/>
-              </a:defRPr>
-            </a:pPr>
-            <a:r>
-              <a:t>SE IT B • ASSIGNED ROLE: QUALITY ASSURANCE &amp; CUSTOM EXCEPTION ARCHITECT • UNIT III &amp; IV TOPIC DEEP DIVE</a:t>
-            </a:r>
-          </a:p>
-        </p:txBody>
-      </p:sp>
-      <p:pic>
-        <p:nvPicPr>
-          <p:cNvPr id="5" name="Picture 4" descr="ait_official_badge.png"/>
-          <p:cNvPicPr>
-            <a:picLocks noChangeAspect="1"/>
-          </p:cNvPicPr>
-          <p:nvPr/>
-        </p:nvPicPr>
-        <p:blipFill>
-          <a:blip r:embed="rId2"/>
-          <a:stretch>
-            <a:fillRect/>
-          </a:stretch>
-        </p:blipFill>
-        <p:spPr>
-          <a:xfrm>
-            <a:off x="10789920" y="320040"/>
-            <a:ext cx="868680" cy="868680"/>
-          </a:xfrm>
-          <a:prstGeom prst="rect">
-            <a:avLst/>
-          </a:prstGeom>
-        </p:spPr>
-      </p:pic>
-      <p:sp>
-        <p:nvSpPr>
-          <p:cNvPr id="6" name="TextBox 5"/>
-          <p:cNvSpPr txBox="1"/>
-          <p:nvPr/>
-        </p:nvSpPr>
-        <p:spPr>
-          <a:xfrm>
-            <a:off x="11155680" y="6400800"/>
-            <a:ext cx="731520" cy="365760"/>
-          </a:xfrm>
-          <a:prstGeom prst="rect">
-            <a:avLst/>
-          </a:prstGeom>
-          <a:noFill/>
-        </p:spPr>
-        <p:txBody>
-          <a:bodyPr wrap="none">
-            <a:spAutoFit/>
-          </a:bodyPr>
-          <a:lstStyle/>
-          <a:p>
-            <a:pPr>
-              <a:defRPr sz="1200">
-                <a:solidFill>
-                  <a:srgbClr val="64748B"/>
-                </a:solidFill>
-                <a:latin typeface="Arial"/>
-              </a:defRPr>
-            </a:pPr>
-            <a:r>
-              <a:t>15</a:t>
-            </a:r>
-          </a:p>
-        </p:txBody>
-      </p:sp>
-      <p:sp>
-        <p:nvSpPr>
-          <p:cNvPr id="7" name="Rounded Rectangle 6"/>
-          <p:cNvSpPr/>
-          <p:nvPr/>
-        </p:nvSpPr>
-        <p:spPr>
-          <a:xfrm>
-            <a:off x="731520" y="1371600"/>
-            <a:ext cx="10728655" cy="685800"/>
-          </a:xfrm>
-          <a:prstGeom prst="roundRect">
-            <a:avLst/>
-          </a:prstGeom>
-          <a:solidFill>
-            <a:srgbClr val="1E293B"/>
-          </a:solidFill>
-          <a:ln w="19050">
-            <a:solidFill>
-              <a:srgbClr val="16A34A"/>
-            </a:solidFill>
-          </a:ln>
-        </p:spPr>
-        <p:style>
-          <a:lnRef idx="1">
-            <a:schemeClr val="accent1"/>
-          </a:lnRef>
-          <a:fillRef idx="3">
-            <a:schemeClr val="accent1"/>
-          </a:fillRef>
-          <a:effectRef idx="2">
-            <a:schemeClr val="accent1"/>
-          </a:effectRef>
-          <a:fontRef idx="minor">
-            <a:schemeClr val="lt1"/>
-          </a:fontRef>
-        </p:style>
-        <p:txBody>
-          <a:bodyPr rtlCol="0" anchor="ctr" wrap="square" lIns="228600" rIns="228600" tIns="109728"/>
-          <a:lstStyle/>
-          <a:p>
-            <a:pPr algn="ctr"/>
-            <a:r>
-              <a:rPr b="1" sz="1300">
-                <a:solidFill>
-                  <a:srgbClr val="FFFFFF"/>
-                </a:solidFill>
-              </a:rPr>
-              <a:t>STUDENT: Utkarsh Chauhan  </a:t>
-            </a:r>
-            <a:r>
-              <a:rPr b="1" sz="1100">
-                <a:solidFill>
-                  <a:srgbClr val="EA580C"/>
-                </a:solidFill>
-              </a:rPr>
-              <a:t>•  ROLL NO: 8154  •  CLASS: SE IT B  •  </a:t>
-            </a:r>
-            <a:r>
-              <a:rPr b="1" sz="1100">
-                <a:solidFill>
-                  <a:srgbClr val="16A34A"/>
-                </a:solidFill>
-              </a:rPr>
-              <a:t>ROLE: Quality Assurance &amp; Custom Exception Architect  •  SPPU BIT25434A0X (CO3, CO4)</a:t>
-            </a:r>
-          </a:p>
-        </p:txBody>
-      </p:sp>
-      <p:sp>
-        <p:nvSpPr>
-          <p:cNvPr id="8" name="Rounded Rectangle 7"/>
-          <p:cNvSpPr/>
-          <p:nvPr/>
-        </p:nvSpPr>
-        <p:spPr>
-          <a:xfrm>
-            <a:off x="731520" y="2148840"/>
-            <a:ext cx="5257800" cy="4389120"/>
-          </a:xfrm>
-          <a:prstGeom prst="roundRect">
-            <a:avLst/>
-          </a:prstGeom>
-          <a:solidFill>
-            <a:srgbClr val="FFFFFF"/>
-          </a:solidFill>
-          <a:ln w="19050">
-            <a:solidFill>
-              <a:srgbClr val="2563EB"/>
-            </a:solidFill>
-          </a:ln>
-        </p:spPr>
-        <p:style>
-          <a:lnRef idx="1">
-            <a:schemeClr val="accent1"/>
-          </a:lnRef>
-          <a:fillRef idx="3">
-            <a:schemeClr val="accent1"/>
-          </a:fillRef>
-          <a:effectRef idx="2">
-            <a:schemeClr val="accent1"/>
-          </a:effectRef>
-          <a:fontRef idx="minor">
-            <a:schemeClr val="lt1"/>
-          </a:fontRef>
-        </p:style>
-        <p:txBody>
-          <a:bodyPr rtlCol="0" anchor="ctr" wrap="square" lIns="182880" rIns="182880" tIns="164592" bIns="164592"/>
-          <a:lstStyle/>
-          <a:p>
-            <a:pPr algn="ctr">
-              <a:spcAft>
-                <a:spcPts val="200"/>
-              </a:spcAft>
-              <a:defRPr sz="850" b="1">
-                <a:solidFill>
-                  <a:srgbClr val="2563EB"/>
-                </a:solidFill>
-                <a:latin typeface="Arial"/>
-              </a:defRPr>
-            </a:pPr>
-            <a:r>
-              <a:t>UNIT III: POLYMORPHISM &amp; INTERFACES</a:t>
-            </a:r>
-          </a:p>
-          <a:p>
-            <a:pPr>
-              <a:spcAft>
-                <a:spcPts val="400"/>
-              </a:spcAft>
-              <a:defRPr sz="1200" b="1">
-                <a:solidFill>
-                  <a:srgbClr val="1B365D"/>
-                </a:solidFill>
-                <a:latin typeface="Arial"/>
-              </a:defRPr>
-            </a:pPr>
-            <a:r>
-              <a:t>Unit III: Interface Implementation &amp; Collections Architecture</a:t>
-            </a:r>
-          </a:p>
-          <a:p>
-            <a:pPr>
-              <a:spcAft>
-                <a:spcPts val="300"/>
-              </a:spcAft>
-            </a:pPr>
-            <a:r>
-              <a:rPr b="1" sz="850">
-                <a:solidFill>
-                  <a:srgbClr val="0F172A"/>
-                </a:solidFill>
-                <a:latin typeface="Arial"/>
-              </a:rPr>
-              <a:t>Syllabus Topic &amp; Definition — </a:t>
-            </a:r>
-            <a:r>
-              <a:rPr sz="850">
-                <a:solidFill>
-                  <a:srgbClr val="0F172A"/>
-                </a:solidFill>
-                <a:latin typeface="Arial"/>
-              </a:rPr>
-              <a:t>Interface Implementation &amp; Collections (SPPU Unit III). Classes implement interface contracts to provide concrete data management. Heterogeneous polymorphic objects are organized using the Java Collections framework (ArrayList, LinkedHashMap) with type-safe generics.</a:t>
-            </a:r>
-          </a:p>
-          <a:p>
-            <a:pPr>
-              <a:spcAft>
-                <a:spcPts val="300"/>
-              </a:spcAft>
-            </a:pPr>
-            <a:r>
-              <a:rPr b="1" sz="850">
-                <a:solidFill>
-                  <a:srgbClr val="0F172A"/>
-                </a:solidFill>
-                <a:latin typeface="Arial"/>
-              </a:rPr>
-              <a:t>Why Used in Architecture — </a:t>
-            </a:r>
-            <a:r>
-              <a:rPr sz="850">
-                <a:solidFill>
-                  <a:srgbClr val="0F172A"/>
-                </a:solidFill>
-                <a:latin typeface="Arial"/>
-              </a:rPr>
-              <a:t>Encapsulates repository operations behind QuizOperations. Storing questions as List&lt;Question&gt; enables polymorphic handling of mixed question types, while LinkedHashMap&lt;String, Quiz&gt; guarantees predictable O(1) lookups and insertion order.</a:t>
-            </a:r>
-          </a:p>
-          <a:p>
-            <a:pPr>
-              <a:spcAft>
-                <a:spcPts val="300"/>
-              </a:spcAft>
-            </a:pPr>
-            <a:r>
-              <a:rPr b="1" sz="850">
-                <a:solidFill>
-                  <a:srgbClr val="0F172A"/>
-                </a:solidFill>
-                <a:latin typeface="Arial"/>
-              </a:rPr>
-              <a:t>Project Implementation — </a:t>
-            </a:r>
-            <a:r>
-              <a:rPr sz="850">
-                <a:solidFill>
-                  <a:srgbClr val="0F172A"/>
-                </a:solidFill>
-                <a:latin typeface="Arial"/>
-              </a:rPr>
-              <a:t>Engineered QuizManager implementing QuizOperations. Manages in-memory quiz registry via Map&lt;String, Quiz&gt; = new LinkedHashMap&lt;&gt;(). Organizes questions polymorphically within Quiz entities using List&lt;Question&gt; = new ArrayList&lt;&gt;().</a:t>
-            </a:r>
-          </a:p>
-          <a:p>
-            <a:pPr>
-              <a:spcAft>
-                <a:spcPts val="300"/>
-              </a:spcAft>
-            </a:pPr>
-            <a:r>
-              <a:rPr b="1" sz="850">
-                <a:solidFill>
-                  <a:srgbClr val="0F172A"/>
-                </a:solidFill>
-                <a:latin typeface="Arial"/>
-              </a:rPr>
-              <a:t>Code Snippet — </a:t>
-            </a:r>
-            <a:r>
-              <a:rPr sz="850">
-                <a:solidFill>
-                  <a:srgbClr val="0F172A"/>
-                </a:solidFill>
-                <a:latin typeface="Arial"/>
-              </a:rPr>
-              <a:t>public class QuizManager implements QuizOperations {
-    private final Map&lt;String, Quiz&gt; repository = new LinkedHashMap&lt;&gt;();
-    @Override
-    public void addQuiz(Quiz q) throws DuplicateQuizException { ... }
-}</a:t>
-            </a:r>
-          </a:p>
-          <a:p>
-            <a:pPr>
-              <a:spcAft>
-                <a:spcPts val="300"/>
-              </a:spcAft>
-            </a:pPr>
-            <a:r>
-              <a:rPr b="1" sz="850">
-                <a:solidFill>
-                  <a:srgbClr val="0F172A"/>
-                </a:solidFill>
-                <a:latin typeface="Arial"/>
-              </a:rPr>
-              <a:t>Viva Defense (Rubric Answer) — </a:t>
-            </a:r>
-            <a:r>
-              <a:rPr sz="850">
-                <a:solidFill>
-                  <a:srgbClr val="0F172A"/>
-                </a:solidFill>
-                <a:latin typeface="Arial"/>
-              </a:rPr>
-              <a:t>Q: How does your implementation achieve loose coupling with collections?
-A: High-level controllers only interact with the interface QuizOperations. If we transition storage from LinkedHashMap to a MySQL database via JDBC, client application code remains completely untouched.</a:t>
-            </a:r>
-          </a:p>
-        </p:txBody>
-      </p:sp>
-      <p:sp>
-        <p:nvSpPr>
-          <p:cNvPr id="9" name="Rounded Rectangle 8"/>
-          <p:cNvSpPr/>
-          <p:nvPr/>
-        </p:nvSpPr>
-        <p:spPr>
-          <a:xfrm>
-            <a:off x="6199632" y="2148840"/>
-            <a:ext cx="5257800" cy="4389120"/>
-          </a:xfrm>
-          <a:prstGeom prst="roundRect">
-            <a:avLst/>
-          </a:prstGeom>
-          <a:solidFill>
-            <a:srgbClr val="FFFFFF"/>
-          </a:solidFill>
-          <a:ln w="19050">
-            <a:solidFill>
-              <a:srgbClr val="EA580C"/>
-            </a:solidFill>
-          </a:ln>
-        </p:spPr>
-        <p:style>
-          <a:lnRef idx="1">
-            <a:schemeClr val="accent1"/>
-          </a:lnRef>
-          <a:fillRef idx="3">
-            <a:schemeClr val="accent1"/>
-          </a:fillRef>
-          <a:effectRef idx="2">
-            <a:schemeClr val="accent1"/>
-          </a:effectRef>
-          <a:fontRef idx="minor">
-            <a:schemeClr val="lt1"/>
-          </a:fontRef>
-        </p:style>
-        <p:txBody>
-          <a:bodyPr rtlCol="0" anchor="ctr" wrap="square" lIns="182880" rIns="182880" tIns="164592" bIns="164592"/>
-          <a:lstStyle/>
-          <a:p>
-            <a:pPr algn="ctr">
-              <a:spcAft>
-                <a:spcPts val="200"/>
-              </a:spcAft>
-              <a:defRPr sz="850" b="1">
-                <a:solidFill>
-                  <a:srgbClr val="2563EB"/>
-                </a:solidFill>
-                <a:latin typeface="Arial"/>
-              </a:defRPr>
-            </a:pPr>
-            <a:r>
-              <a:t>UNIT IV: ERROR &amp; EXCEPTION HANDLING</a:t>
-            </a:r>
-          </a:p>
-          <a:p>
-            <a:pPr>
-              <a:spcAft>
-                <a:spcPts val="400"/>
-              </a:spcAft>
-              <a:defRPr sz="1200" b="1">
-                <a:solidFill>
-                  <a:srgbClr val="1B365D"/>
-                </a:solidFill>
-                <a:latin typeface="Arial"/>
-              </a:defRPr>
-            </a:pPr>
-            <a:r>
-              <a:t>Unit IV: User-Defined Checked Exceptions &amp; Zero-Crash Interception</a:t>
-            </a:r>
-          </a:p>
-          <a:p>
-            <a:pPr>
-              <a:spcAft>
-                <a:spcPts val="300"/>
-              </a:spcAft>
-            </a:pPr>
-            <a:r>
-              <a:rPr b="1" sz="850">
-                <a:solidFill>
-                  <a:srgbClr val="0F172A"/>
-                </a:solidFill>
-                <a:latin typeface="Arial"/>
-              </a:rPr>
-              <a:t>Syllabus Topic &amp; Definition — </a:t>
-            </a:r>
-            <a:r>
-              <a:rPr sz="850">
-                <a:solidFill>
-                  <a:srgbClr val="0F172A"/>
-                </a:solidFill>
-                <a:latin typeface="Arial"/>
-              </a:rPr>
-              <a:t>User-Defined Exceptions (SPPU Unit IV). Custom exceptions extend java.lang.Exception to represent distinct business failure scenarios. Combined with defensive input loops, they prevent unhandled aborts and provide domain-specific diagnostic feedback.</a:t>
-            </a:r>
-          </a:p>
-          <a:p>
-            <a:pPr>
-              <a:spcAft>
-                <a:spcPts val="300"/>
-              </a:spcAft>
-            </a:pPr>
-            <a:r>
-              <a:rPr b="1" sz="850">
-                <a:solidFill>
-                  <a:srgbClr val="0F172A"/>
-                </a:solidFill>
-                <a:latin typeface="Arial"/>
-              </a:rPr>
-              <a:t>Operational Failure &amp; Mitigation — </a:t>
-            </a:r>
-            <a:r>
-              <a:rPr sz="850">
-                <a:solidFill>
-                  <a:srgbClr val="0F172A"/>
-                </a:solidFill>
-                <a:latin typeface="Arial"/>
-              </a:rPr>
-              <a:t>Typographical mistakes by students (e.g. entering 'Z' or special symbols) traditionally cause fatal console crashes, ruining examination flow and causing frustration.</a:t>
-            </a:r>
-          </a:p>
-          <a:p>
-            <a:pPr>
-              <a:spcAft>
-                <a:spcPts val="300"/>
-              </a:spcAft>
-            </a:pPr>
-            <a:r>
-              <a:rPr b="1" sz="850">
-                <a:solidFill>
-                  <a:srgbClr val="0F172A"/>
-                </a:solidFill>
-                <a:latin typeface="Arial"/>
-              </a:rPr>
-              <a:t>Project Implementation — </a:t>
-            </a:r>
-            <a:r>
-              <a:rPr sz="850">
-                <a:solidFill>
-                  <a:srgbClr val="0F172A"/>
-                </a:solidFill>
-                <a:latin typeface="Arial"/>
-              </a:rPr>
-              <a:t>Engineered 5-tier checked exception hierarchy rooted at QuizException: QuizNotFoundException, DuplicateQuizException, InvalidOptionException, InvalidQuestionException, and EmptyQuizException. Built defensive InputValidator with while(true) loops wrapping NumberFormatException. Built run_tests.bat.</a:t>
-            </a:r>
-          </a:p>
-          <a:p>
-            <a:pPr>
-              <a:spcAft>
-                <a:spcPts val="300"/>
-              </a:spcAft>
-            </a:pPr>
-            <a:r>
-              <a:rPr b="1" sz="850">
-                <a:solidFill>
-                  <a:srgbClr val="0F172A"/>
-                </a:solidFill>
-                <a:latin typeface="Arial"/>
-              </a:rPr>
-              <a:t>Code Snippet — </a:t>
-            </a:r>
-            <a:r>
-              <a:rPr sz="850">
-                <a:solidFill>
-                  <a:srgbClr val="0F172A"/>
-                </a:solidFill>
-                <a:latin typeface="Arial"/>
-              </a:rPr>
-              <a:t>public class InvalidOptionException extends QuizException {
-    public InvalidOptionException(String msg) {
-        super("INVALID OPTION: " + msg);
-    }
-}
-// Zero-crash input loop:
-while(true) { try { return Integer.parseInt(s.nextLine()); }
-catch(NumberFormatException e) { System.out.print("Invalid. Re-enter: "); } }</a:t>
-            </a:r>
-          </a:p>
-          <a:p>
-            <a:pPr>
-              <a:spcAft>
-                <a:spcPts val="300"/>
-              </a:spcAft>
-            </a:pPr>
-            <a:r>
-              <a:rPr b="1" sz="850">
-                <a:solidFill>
-                  <a:srgbClr val="0F172A"/>
-                </a:solidFill>
-                <a:latin typeface="Arial"/>
-              </a:rPr>
-              <a:t>Viva Defense (Rubric Answer) — </a:t>
-            </a:r>
-            <a:r>
-              <a:rPr sz="850">
-                <a:solidFill>
-                  <a:srgbClr val="0F172A"/>
-                </a:solidFill>
-                <a:latin typeface="Arial"/>
-              </a:rPr>
-              <a:t>Q: What custom exceptions can occur and how are they handled?
-A: 5 custom checked exceptions exist. Every exception is intercepted with targeted try-catch blocks that print actionable feedback and allow the student/faculty to recover without crashing the JVM.</a:t>
-            </a:r>
-          </a:p>
-        </p:txBody>
-      </p:sp>
-    </p:spTree>
-  </p:cSld>
-  <p:clrMapOvr>
-    <a:masterClrMapping/>
-  </p:clrMapOvr>
-</p:sld>
-</file>
-
-<file path=ppt/slides/slide16.xml><?xml version="1.0" encoding="utf-8"?>
-<p:sld xmlns:a="http://schemas.openxmlformats.org/drawingml/2006/main" xmlns:p="http://schemas.openxmlformats.org/presentationml/2006/main" xmlns:r="http://schemas.openxmlformats.org/officeDocument/2006/relationships">
-  <p:cSld>
-    <p:spTree>
-      <p:nvGrpSpPr>
-        <p:cNvPr id="1" name=""/>
-        <p:cNvGrpSpPr/>
-        <p:nvPr/>
-      </p:nvGrpSpPr>
-      <p:grpSpPr/>
-      <p:sp>
-        <p:nvSpPr>
-          <p:cNvPr id="2" name="Rectangle 1"/>
-          <p:cNvSpPr/>
-          <p:nvPr/>
-        </p:nvSpPr>
-        <p:spPr>
-          <a:xfrm>
-            <a:off x="0" y="0"/>
-            <a:ext cx="12191695" cy="6858000"/>
-          </a:xfrm>
-          <a:prstGeom prst="rect">
-            <a:avLst/>
-          </a:prstGeom>
-          <a:solidFill>
-            <a:srgbClr val="FBF9F4"/>
-          </a:solidFill>
-          <a:ln>
-            <a:noFill/>
-          </a:ln>
-        </p:spPr>
-        <p:style>
-          <a:lnRef idx="1">
-            <a:schemeClr val="accent1"/>
-          </a:lnRef>
-          <a:fillRef idx="3">
-            <a:schemeClr val="accent1"/>
-          </a:fillRef>
-          <a:effectRef idx="2">
-            <a:schemeClr val="accent1"/>
-          </a:effectRef>
-          <a:fontRef idx="minor">
-            <a:schemeClr val="lt1"/>
-          </a:fontRef>
-        </p:style>
-        <p:txBody>
-          <a:bodyPr rtlCol="0" anchor="ctr"/>
-          <a:lstStyle/>
-          <a:p>
-            <a:pPr algn="ctr"/>
-          </a:p>
-        </p:txBody>
-      </p:sp>
-      <p:sp>
-        <p:nvSpPr>
-          <p:cNvPr id="3" name="Rectangle 2"/>
-          <p:cNvSpPr/>
-          <p:nvPr/>
-        </p:nvSpPr>
-        <p:spPr>
-          <a:xfrm>
-            <a:off x="731520" y="365760"/>
-            <a:ext cx="10698480" cy="36576"/>
-          </a:xfrm>
-          <a:prstGeom prst="rect">
-            <a:avLst/>
-          </a:prstGeom>
-          <a:solidFill>
-            <a:srgbClr val="1B365D"/>
-          </a:solidFill>
-          <a:ln>
-            <a:noFill/>
-          </a:ln>
-        </p:spPr>
-        <p:style>
-          <a:lnRef idx="1">
-            <a:schemeClr val="accent1"/>
-          </a:lnRef>
-          <a:fillRef idx="3">
-            <a:schemeClr val="accent1"/>
-          </a:fillRef>
-          <a:effectRef idx="2">
-            <a:schemeClr val="accent1"/>
-          </a:effectRef>
-          <a:fontRef idx="minor">
-            <a:schemeClr val="lt1"/>
-          </a:fontRef>
-        </p:style>
-        <p:txBody>
-          <a:bodyPr rtlCol="0" anchor="ctr"/>
-          <a:lstStyle/>
-          <a:p>
-            <a:pPr algn="ctr"/>
-          </a:p>
-        </p:txBody>
-      </p:sp>
-      <p:sp>
-        <p:nvSpPr>
-          <p:cNvPr id="4" name="TextBox 3"/>
-          <p:cNvSpPr txBox="1"/>
-          <p:nvPr/>
-        </p:nvSpPr>
-        <p:spPr>
-          <a:xfrm>
-            <a:off x="731520" y="411480"/>
-            <a:ext cx="9326880" cy="822960"/>
-          </a:xfrm>
-          <a:prstGeom prst="rect">
-            <a:avLst/>
-          </a:prstGeom>
-          <a:noFill/>
-        </p:spPr>
-        <p:txBody>
-          <a:bodyPr wrap="square" lIns="0" tIns="0" rIns="0" bIns="0">
-            <a:spAutoFit/>
-          </a:bodyPr>
-          <a:lstStyle/>
-          <a:p>
-            <a:pPr>
-              <a:defRPr sz="2200" b="1">
-                <a:solidFill>
-                  <a:srgbClr val="1B365D"/>
-                </a:solidFill>
-                <a:latin typeface="Arial"/>
-              </a:defRPr>
-            </a:pPr>
-            <a:r>
-              <a:t>CONTINUOUS PROJECT ROADMAP &amp; ACADEMIC REFERENCES</a:t>
-            </a:r>
-          </a:p>
-          <a:p>
-            <a:pPr>
-              <a:defRPr sz="1100" b="1">
-                <a:solidFill>
-                  <a:srgbClr val="EA580C"/>
-                </a:solidFill>
-                <a:latin typeface="Arial"/>
-              </a:defRPr>
-            </a:pPr>
-            <a:r>
-              <a:t>EXPANSION PHASES &amp; OFFICIAL COURSE CITATIONS</a:t>
-            </a:r>
-          </a:p>
-        </p:txBody>
-      </p:sp>
-      <p:pic>
-        <p:nvPicPr>
-          <p:cNvPr id="5" name="Picture 4" descr="ait_official_badge.png"/>
-          <p:cNvPicPr>
-            <a:picLocks noChangeAspect="1"/>
-          </p:cNvPicPr>
-          <p:nvPr/>
-        </p:nvPicPr>
-        <p:blipFill>
-          <a:blip r:embed="rId2"/>
-          <a:stretch>
-            <a:fillRect/>
-          </a:stretch>
-        </p:blipFill>
-        <p:spPr>
-          <a:xfrm>
-            <a:off x="10789920" y="320040"/>
-            <a:ext cx="868680" cy="868680"/>
-          </a:xfrm>
-          <a:prstGeom prst="rect">
-            <a:avLst/>
-          </a:prstGeom>
-        </p:spPr>
-      </p:pic>
-      <p:sp>
-        <p:nvSpPr>
-          <p:cNvPr id="6" name="TextBox 5"/>
-          <p:cNvSpPr txBox="1"/>
-          <p:nvPr/>
-        </p:nvSpPr>
-        <p:spPr>
-          <a:xfrm>
-            <a:off x="11155680" y="6400800"/>
-            <a:ext cx="731520" cy="365760"/>
-          </a:xfrm>
-          <a:prstGeom prst="rect">
-            <a:avLst/>
-          </a:prstGeom>
-          <a:noFill/>
-        </p:spPr>
-        <p:txBody>
-          <a:bodyPr wrap="none">
-            <a:spAutoFit/>
-          </a:bodyPr>
-          <a:lstStyle/>
-          <a:p>
-            <a:pPr>
-              <a:defRPr sz="1200">
-                <a:solidFill>
-                  <a:srgbClr val="64748B"/>
-                </a:solidFill>
-                <a:latin typeface="Arial"/>
-              </a:defRPr>
-            </a:pPr>
-            <a:r>
-              <a:t>16</a:t>
             </a:r>
           </a:p>
         </p:txBody>

</xml_diff>